<commit_message>
Verification pass 6: deliverables derive statements from result files, dashboard chart fixes, report corrections, mutation-tested Phase 8
</commit_message>
<xml_diff>
--- a/docs/EnduroSense_Slides.pptx
+++ b/docs/EnduroSense_Slides.pptx
@@ -202,7 +202,7 @@
             </a:lvl1pPr>
           </a:lstStyle>
           <a:p>
-            <a:fld id="{B1EA036E-03B3-478A-962B-AD7B120C4DF5}" type="datetimeFigureOut">
+            <a:fld id="{5A9119FD-76A5-461B-B4E2-112CBCD92D0C}" type="datetimeFigureOut">
               <a:rPr lang="en-IN" smtClean="0"/>
               <a:t>04-10-2026</a:t>
             </a:fld>
@@ -361,7 +361,7 @@
             </a:lvl1pPr>
           </a:lstStyle>
           <a:p>
-            <a:fld id="{EF107FF8-E939-4572-94B9-554E7A5AF3A7}" type="slidenum">
+            <a:fld id="{389D68E7-BC36-4BC6-A31A-FA07550A78D9}" type="slidenum">
               <a:rPr lang="en-IN" smtClean="0"/>
               <a:t>‹#›</a:t>
             </a:fld>
@@ -372,7 +372,7 @@
     </p:spTree>
     <p:extLst>
       <p:ext uri="{BB962C8B-B14F-4D97-AF65-F5344CB8AC3E}">
-        <p14:creationId xmlns:p14="http://schemas.microsoft.com/office/powerpoint/2010/main" val="985960116"/>
+        <p14:creationId xmlns:p14="http://schemas.microsoft.com/office/powerpoint/2010/main" val="2941722230"/>
       </p:ext>
     </p:extLst>
   </p:cSld>
@@ -539,7 +539,7 @@
           <a:bodyPr/>
           <a:lstStyle/>
           <a:p>
-            <a:fld id="{EF107FF8-E939-4572-94B9-554E7A5AF3A7}" type="slidenum">
+            <a:fld id="{389D68E7-BC36-4BC6-A31A-FA07550A78D9}" type="slidenum">
               <a:rPr lang="en-IN" smtClean="0"/>
               <a:t>1</a:t>
             </a:fld>
@@ -550,7 +550,7 @@
     </p:spTree>
     <p:extLst>
       <p:ext uri="{BB962C8B-B14F-4D97-AF65-F5344CB8AC3E}">
-        <p14:creationId xmlns:p14="http://schemas.microsoft.com/office/powerpoint/2010/main" val="144432728"/>
+        <p14:creationId xmlns:p14="http://schemas.microsoft.com/office/powerpoint/2010/main" val="4172993569"/>
       </p:ext>
     </p:extLst>
   </p:cSld>
@@ -606,7 +606,7 @@
           <a:p>
             <a:r>
               <a:rPr lang="en-US"/>
-              <a:t>Only the pairing of batteries with tasks is simulated. Best estimates plus a fixed margin tuned in development does about as well as EnduroSense here.</a:t>
+              <a:t>Only the pairing of batteries with tasks is simulated. Best estimates plus a fixed margin tuned in development sits close to EnduroSense here: slightly fewer unsafe missions, more battery swaps.</a:t>
             </a:r>
             <a:endParaRPr lang="en-IN"/>
           </a:p>
@@ -627,7 +627,7 @@
           <a:bodyPr/>
           <a:lstStyle/>
           <a:p>
-            <a:fld id="{EF107FF8-E939-4572-94B9-554E7A5AF3A7}" type="slidenum">
+            <a:fld id="{389D68E7-BC36-4BC6-A31A-FA07550A78D9}" type="slidenum">
               <a:rPr lang="en-IN" smtClean="0"/>
               <a:t>10</a:t>
             </a:fld>
@@ -638,7 +638,7 @@
     </p:spTree>
     <p:extLst>
       <p:ext uri="{BB962C8B-B14F-4D97-AF65-F5344CB8AC3E}">
-        <p14:creationId xmlns:p14="http://schemas.microsoft.com/office/powerpoint/2010/main" val="3660110444"/>
+        <p14:creationId xmlns:p14="http://schemas.microsoft.com/office/powerpoint/2010/main" val="3075957460"/>
       </p:ext>
     </p:extLst>
   </p:cSld>
@@ -715,7 +715,7 @@
           <a:bodyPr/>
           <a:lstStyle/>
           <a:p>
-            <a:fld id="{EF107FF8-E939-4572-94B9-554E7A5AF3A7}" type="slidenum">
+            <a:fld id="{389D68E7-BC36-4BC6-A31A-FA07550A78D9}" type="slidenum">
               <a:rPr lang="en-IN" smtClean="0"/>
               <a:t>11</a:t>
             </a:fld>
@@ -726,7 +726,7 @@
     </p:spTree>
     <p:extLst>
       <p:ext uri="{BB962C8B-B14F-4D97-AF65-F5344CB8AC3E}">
-        <p14:creationId xmlns:p14="http://schemas.microsoft.com/office/powerpoint/2010/main" val="4159633217"/>
+        <p14:creationId xmlns:p14="http://schemas.microsoft.com/office/powerpoint/2010/main" val="583663525"/>
       </p:ext>
     </p:extLst>
   </p:cSld>
@@ -803,7 +803,7 @@
           <a:bodyPr/>
           <a:lstStyle/>
           <a:p>
-            <a:fld id="{EF107FF8-E939-4572-94B9-554E7A5AF3A7}" type="slidenum">
+            <a:fld id="{389D68E7-BC36-4BC6-A31A-FA07550A78D9}" type="slidenum">
               <a:rPr lang="en-IN" smtClean="0"/>
               <a:t>12</a:t>
             </a:fld>
@@ -814,7 +814,7 @@
     </p:spTree>
     <p:extLst>
       <p:ext uri="{BB962C8B-B14F-4D97-AF65-F5344CB8AC3E}">
-        <p14:creationId xmlns:p14="http://schemas.microsoft.com/office/powerpoint/2010/main" val="2415905299"/>
+        <p14:creationId xmlns:p14="http://schemas.microsoft.com/office/powerpoint/2010/main" val="3464575937"/>
       </p:ext>
     </p:extLst>
   </p:cSld>
@@ -891,7 +891,7 @@
           <a:bodyPr/>
           <a:lstStyle/>
           <a:p>
-            <a:fld id="{EF107FF8-E939-4572-94B9-554E7A5AF3A7}" type="slidenum">
+            <a:fld id="{389D68E7-BC36-4BC6-A31A-FA07550A78D9}" type="slidenum">
               <a:rPr lang="en-IN" smtClean="0"/>
               <a:t>13</a:t>
             </a:fld>
@@ -902,7 +902,7 @@
     </p:spTree>
     <p:extLst>
       <p:ext uri="{BB962C8B-B14F-4D97-AF65-F5344CB8AC3E}">
-        <p14:creationId xmlns:p14="http://schemas.microsoft.com/office/powerpoint/2010/main" val="3057343722"/>
+        <p14:creationId xmlns:p14="http://schemas.microsoft.com/office/powerpoint/2010/main" val="3238997394"/>
       </p:ext>
     </p:extLst>
   </p:cSld>
@@ -979,7 +979,7 @@
           <a:bodyPr/>
           <a:lstStyle/>
           <a:p>
-            <a:fld id="{EF107FF8-E939-4572-94B9-554E7A5AF3A7}" type="slidenum">
+            <a:fld id="{389D68E7-BC36-4BC6-A31A-FA07550A78D9}" type="slidenum">
               <a:rPr lang="en-IN" smtClean="0"/>
               <a:t>2</a:t>
             </a:fld>
@@ -990,7 +990,7 @@
     </p:spTree>
     <p:extLst>
       <p:ext uri="{BB962C8B-B14F-4D97-AF65-F5344CB8AC3E}">
-        <p14:creationId xmlns:p14="http://schemas.microsoft.com/office/powerpoint/2010/main" val="1200902887"/>
+        <p14:creationId xmlns:p14="http://schemas.microsoft.com/office/powerpoint/2010/main" val="2189022007"/>
       </p:ext>
     </p:extLst>
   </p:cSld>
@@ -1067,7 +1067,7 @@
           <a:bodyPr/>
           <a:lstStyle/>
           <a:p>
-            <a:fld id="{EF107FF8-E939-4572-94B9-554E7A5AF3A7}" type="slidenum">
+            <a:fld id="{389D68E7-BC36-4BC6-A31A-FA07550A78D9}" type="slidenum">
               <a:rPr lang="en-IN" smtClean="0"/>
               <a:t>3</a:t>
             </a:fld>
@@ -1078,7 +1078,7 @@
     </p:spTree>
     <p:extLst>
       <p:ext uri="{BB962C8B-B14F-4D97-AF65-F5344CB8AC3E}">
-        <p14:creationId xmlns:p14="http://schemas.microsoft.com/office/powerpoint/2010/main" val="990493629"/>
+        <p14:creationId xmlns:p14="http://schemas.microsoft.com/office/powerpoint/2010/main" val="1179198282"/>
       </p:ext>
     </p:extLst>
   </p:cSld>
@@ -1155,7 +1155,7 @@
           <a:bodyPr/>
           <a:lstStyle/>
           <a:p>
-            <a:fld id="{EF107FF8-E939-4572-94B9-554E7A5AF3A7}" type="slidenum">
+            <a:fld id="{389D68E7-BC36-4BC6-A31A-FA07550A78D9}" type="slidenum">
               <a:rPr lang="en-IN" smtClean="0"/>
               <a:t>4</a:t>
             </a:fld>
@@ -1166,7 +1166,7 @@
     </p:spTree>
     <p:extLst>
       <p:ext uri="{BB962C8B-B14F-4D97-AF65-F5344CB8AC3E}">
-        <p14:creationId xmlns:p14="http://schemas.microsoft.com/office/powerpoint/2010/main" val="300669887"/>
+        <p14:creationId xmlns:p14="http://schemas.microsoft.com/office/powerpoint/2010/main" val="2000644601"/>
       </p:ext>
     </p:extLst>
   </p:cSld>
@@ -1243,7 +1243,7 @@
           <a:bodyPr/>
           <a:lstStyle/>
           <a:p>
-            <a:fld id="{EF107FF8-E939-4572-94B9-554E7A5AF3A7}" type="slidenum">
+            <a:fld id="{389D68E7-BC36-4BC6-A31A-FA07550A78D9}" type="slidenum">
               <a:rPr lang="en-IN" smtClean="0"/>
               <a:t>5</a:t>
             </a:fld>
@@ -1254,7 +1254,7 @@
     </p:spTree>
     <p:extLst>
       <p:ext uri="{BB962C8B-B14F-4D97-AF65-F5344CB8AC3E}">
-        <p14:creationId xmlns:p14="http://schemas.microsoft.com/office/powerpoint/2010/main" val="1487990086"/>
+        <p14:creationId xmlns:p14="http://schemas.microsoft.com/office/powerpoint/2010/main" val="93027013"/>
       </p:ext>
     </p:extLst>
   </p:cSld>
@@ -1331,7 +1331,7 @@
           <a:bodyPr/>
           <a:lstStyle/>
           <a:p>
-            <a:fld id="{EF107FF8-E939-4572-94B9-554E7A5AF3A7}" type="slidenum">
+            <a:fld id="{389D68E7-BC36-4BC6-A31A-FA07550A78D9}" type="slidenum">
               <a:rPr lang="en-IN" smtClean="0"/>
               <a:t>6</a:t>
             </a:fld>
@@ -1342,7 +1342,7 @@
     </p:spTree>
     <p:extLst>
       <p:ext uri="{BB962C8B-B14F-4D97-AF65-F5344CB8AC3E}">
-        <p14:creationId xmlns:p14="http://schemas.microsoft.com/office/powerpoint/2010/main" val="2431055532"/>
+        <p14:creationId xmlns:p14="http://schemas.microsoft.com/office/powerpoint/2010/main" val="2385526873"/>
       </p:ext>
     </p:extLst>
   </p:cSld>
@@ -1398,7 +1398,7 @@
           <a:p>
             <a:r>
               <a:rPr lang="en-US"/>
-              <a:t>Model A's ranges held on test. Model B's were too narrow on new data (80% against 90%): a real weakness, reported as such.</a:t>
+              <a:t>Model A's ranges were about right on test (93.8%, slightly wide). Model B's were too narrow on new data (80% against 90%): a real weakness, reported as such.</a:t>
             </a:r>
             <a:endParaRPr lang="en-IN"/>
           </a:p>
@@ -1419,7 +1419,7 @@
           <a:bodyPr/>
           <a:lstStyle/>
           <a:p>
-            <a:fld id="{EF107FF8-E939-4572-94B9-554E7A5AF3A7}" type="slidenum">
+            <a:fld id="{389D68E7-BC36-4BC6-A31A-FA07550A78D9}" type="slidenum">
               <a:rPr lang="en-IN" smtClean="0"/>
               <a:t>7</a:t>
             </a:fld>
@@ -1430,7 +1430,7 @@
     </p:spTree>
     <p:extLst>
       <p:ext uri="{BB962C8B-B14F-4D97-AF65-F5344CB8AC3E}">
-        <p14:creationId xmlns:p14="http://schemas.microsoft.com/office/powerpoint/2010/main" val="3091190200"/>
+        <p14:creationId xmlns:p14="http://schemas.microsoft.com/office/powerpoint/2010/main" val="2360114082"/>
       </p:ext>
     </p:extLst>
   </p:cSld>
@@ -1507,7 +1507,7 @@
           <a:bodyPr/>
           <a:lstStyle/>
           <a:p>
-            <a:fld id="{EF107FF8-E939-4572-94B9-554E7A5AF3A7}" type="slidenum">
+            <a:fld id="{389D68E7-BC36-4BC6-A31A-FA07550A78D9}" type="slidenum">
               <a:rPr lang="en-IN" smtClean="0"/>
               <a:t>8</a:t>
             </a:fld>
@@ -1518,7 +1518,7 @@
     </p:spTree>
     <p:extLst>
       <p:ext uri="{BB962C8B-B14F-4D97-AF65-F5344CB8AC3E}">
-        <p14:creationId xmlns:p14="http://schemas.microsoft.com/office/powerpoint/2010/main" val="513349228"/>
+        <p14:creationId xmlns:p14="http://schemas.microsoft.com/office/powerpoint/2010/main" val="3600516394"/>
       </p:ext>
     </p:extLst>
   </p:cSld>
@@ -1595,7 +1595,7 @@
           <a:bodyPr/>
           <a:lstStyle/>
           <a:p>
-            <a:fld id="{EF107FF8-E939-4572-94B9-554E7A5AF3A7}" type="slidenum">
+            <a:fld id="{389D68E7-BC36-4BC6-A31A-FA07550A78D9}" type="slidenum">
               <a:rPr lang="en-IN" smtClean="0"/>
               <a:t>9</a:t>
             </a:fld>
@@ -1606,7 +1606,7 @@
     </p:spTree>
     <p:extLst>
       <p:ext uri="{BB962C8B-B14F-4D97-AF65-F5344CB8AC3E}">
-        <p14:creationId xmlns:p14="http://schemas.microsoft.com/office/powerpoint/2010/main" val="3878720993"/>
+        <p14:creationId xmlns:p14="http://schemas.microsoft.com/office/powerpoint/2010/main" val="3028247281"/>
       </p:ext>
     </p:extLst>
   </p:cSld>
@@ -1638,7 +1638,7 @@
           <p:cNvPr id="2" name="Title 1">
             <a:extLst>
               <a:ext uri="{FF2B5EF4-FFF2-40B4-BE49-F238E27FC236}">
-                <a16:creationId xmlns:a16="http://schemas.microsoft.com/office/drawing/2014/main" id="{312E901D-CA1A-04BB-2D59-F6BB920C1124}"/>
+                <a16:creationId xmlns:a16="http://schemas.microsoft.com/office/drawing/2014/main" id="{C76FDE9D-949E-AC75-CC18-4BB3CBF2D412}"/>
               </a:ext>
             </a:extLst>
           </p:cNvPr>
@@ -1676,7 +1676,7 @@
           <p:cNvPr id="3" name="Subtitle 2">
             <a:extLst>
               <a:ext uri="{FF2B5EF4-FFF2-40B4-BE49-F238E27FC236}">
-                <a16:creationId xmlns:a16="http://schemas.microsoft.com/office/drawing/2014/main" id="{97B6B16C-68F5-9F91-ED1D-3FC33898F1A2}"/>
+                <a16:creationId xmlns:a16="http://schemas.microsoft.com/office/drawing/2014/main" id="{42F682D8-0B7D-11BD-C03C-212E3862054D}"/>
               </a:ext>
             </a:extLst>
           </p:cNvPr>
@@ -1747,7 +1747,7 @@
           <p:cNvPr id="4" name="Date Placeholder 3">
             <a:extLst>
               <a:ext uri="{FF2B5EF4-FFF2-40B4-BE49-F238E27FC236}">
-                <a16:creationId xmlns:a16="http://schemas.microsoft.com/office/drawing/2014/main" id="{43E7A27B-3C79-B923-E605-0974381C8FA4}"/>
+                <a16:creationId xmlns:a16="http://schemas.microsoft.com/office/drawing/2014/main" id="{C7F27312-E3E9-7665-80BC-50C7AB959A85}"/>
               </a:ext>
             </a:extLst>
           </p:cNvPr>
@@ -1763,7 +1763,7 @@
           <a:bodyPr/>
           <a:lstStyle/>
           <a:p>
-            <a:fld id="{41347811-5AC3-4474-A815-5801572B89F9}" type="datetimeFigureOut">
+            <a:fld id="{0DB4BE67-C782-407E-AB74-B6F0632D8A8C}" type="datetimeFigureOut">
               <a:rPr lang="en-IN" smtClean="0"/>
               <a:t>04-10-2026</a:t>
             </a:fld>
@@ -1776,7 +1776,7 @@
           <p:cNvPr id="5" name="Footer Placeholder 4">
             <a:extLst>
               <a:ext uri="{FF2B5EF4-FFF2-40B4-BE49-F238E27FC236}">
-                <a16:creationId xmlns:a16="http://schemas.microsoft.com/office/drawing/2014/main" id="{DC027E25-2274-C5E8-D73C-195BC2B35787}"/>
+                <a16:creationId xmlns:a16="http://schemas.microsoft.com/office/drawing/2014/main" id="{0FCF40CC-2BE0-521D-5B17-F2DD9B38EC63}"/>
               </a:ext>
             </a:extLst>
           </p:cNvPr>
@@ -1801,7 +1801,7 @@
           <p:cNvPr id="6" name="Slide Number Placeholder 5">
             <a:extLst>
               <a:ext uri="{FF2B5EF4-FFF2-40B4-BE49-F238E27FC236}">
-                <a16:creationId xmlns:a16="http://schemas.microsoft.com/office/drawing/2014/main" id="{8C5EA7B0-A7E8-9573-E54A-F9E364ED064F}"/>
+                <a16:creationId xmlns:a16="http://schemas.microsoft.com/office/drawing/2014/main" id="{0E3DAF0A-87BC-B569-2CE4-D360DB8AD122}"/>
               </a:ext>
             </a:extLst>
           </p:cNvPr>
@@ -1817,7 +1817,7 @@
           <a:bodyPr/>
           <a:lstStyle/>
           <a:p>
-            <a:fld id="{2FC1135E-8EC1-4654-A988-9EF69C99888A}" type="slidenum">
+            <a:fld id="{DA029E50-C3D9-45BC-89A7-75ED05AA6FB2}" type="slidenum">
               <a:rPr lang="en-IN" smtClean="0"/>
               <a:t>‹#›</a:t>
             </a:fld>
@@ -1828,7 +1828,7 @@
     </p:spTree>
     <p:extLst>
       <p:ext uri="{BB962C8B-B14F-4D97-AF65-F5344CB8AC3E}">
-        <p14:creationId xmlns:p14="http://schemas.microsoft.com/office/powerpoint/2010/main" val="1693702512"/>
+        <p14:creationId xmlns:p14="http://schemas.microsoft.com/office/powerpoint/2010/main" val="4259045691"/>
       </p:ext>
     </p:extLst>
   </p:cSld>
@@ -1860,7 +1860,7 @@
           <p:cNvPr id="2" name="Title 1">
             <a:extLst>
               <a:ext uri="{FF2B5EF4-FFF2-40B4-BE49-F238E27FC236}">
-                <a16:creationId xmlns:a16="http://schemas.microsoft.com/office/drawing/2014/main" id="{52F07567-C1E9-0CB1-C08C-93EB96F028F2}"/>
+                <a16:creationId xmlns:a16="http://schemas.microsoft.com/office/drawing/2014/main" id="{281D841E-7389-3557-6EA5-85D5A2D14F8A}"/>
               </a:ext>
             </a:extLst>
           </p:cNvPr>
@@ -1889,7 +1889,7 @@
           <p:cNvPr id="3" name="Vertical Text Placeholder 2">
             <a:extLst>
               <a:ext uri="{FF2B5EF4-FFF2-40B4-BE49-F238E27FC236}">
-                <a16:creationId xmlns:a16="http://schemas.microsoft.com/office/drawing/2014/main" id="{1D13311A-CB90-F10C-75A4-2AEBB0A630A2}"/>
+                <a16:creationId xmlns:a16="http://schemas.microsoft.com/office/drawing/2014/main" id="{7E675EE7-4A25-C14C-AE83-685127BF8294}"/>
               </a:ext>
             </a:extLst>
           </p:cNvPr>
@@ -1947,7 +1947,7 @@
           <p:cNvPr id="4" name="Date Placeholder 3">
             <a:extLst>
               <a:ext uri="{FF2B5EF4-FFF2-40B4-BE49-F238E27FC236}">
-                <a16:creationId xmlns:a16="http://schemas.microsoft.com/office/drawing/2014/main" id="{D8B0139B-3E5D-83FB-4DBE-D57AD1424ED3}"/>
+                <a16:creationId xmlns:a16="http://schemas.microsoft.com/office/drawing/2014/main" id="{DC83F56B-BF78-830D-890B-7139B3B4048D}"/>
               </a:ext>
             </a:extLst>
           </p:cNvPr>
@@ -1963,7 +1963,7 @@
           <a:bodyPr/>
           <a:lstStyle/>
           <a:p>
-            <a:fld id="{41347811-5AC3-4474-A815-5801572B89F9}" type="datetimeFigureOut">
+            <a:fld id="{0DB4BE67-C782-407E-AB74-B6F0632D8A8C}" type="datetimeFigureOut">
               <a:rPr lang="en-IN" smtClean="0"/>
               <a:t>04-10-2026</a:t>
             </a:fld>
@@ -1976,7 +1976,7 @@
           <p:cNvPr id="5" name="Footer Placeholder 4">
             <a:extLst>
               <a:ext uri="{FF2B5EF4-FFF2-40B4-BE49-F238E27FC236}">
-                <a16:creationId xmlns:a16="http://schemas.microsoft.com/office/drawing/2014/main" id="{0E6C67EB-8818-3B0E-B7C9-2E4A5DD8A162}"/>
+                <a16:creationId xmlns:a16="http://schemas.microsoft.com/office/drawing/2014/main" id="{1AB124A1-FFDD-19C9-E03E-85054DFBC867}"/>
               </a:ext>
             </a:extLst>
           </p:cNvPr>
@@ -2001,7 +2001,7 @@
           <p:cNvPr id="6" name="Slide Number Placeholder 5">
             <a:extLst>
               <a:ext uri="{FF2B5EF4-FFF2-40B4-BE49-F238E27FC236}">
-                <a16:creationId xmlns:a16="http://schemas.microsoft.com/office/drawing/2014/main" id="{F8977F15-6B00-8C49-C99A-A2C28E67F0AC}"/>
+                <a16:creationId xmlns:a16="http://schemas.microsoft.com/office/drawing/2014/main" id="{26802B19-7439-CA3B-DCD4-AB1EC5A4B160}"/>
               </a:ext>
             </a:extLst>
           </p:cNvPr>
@@ -2017,7 +2017,7 @@
           <a:bodyPr/>
           <a:lstStyle/>
           <a:p>
-            <a:fld id="{2FC1135E-8EC1-4654-A988-9EF69C99888A}" type="slidenum">
+            <a:fld id="{DA029E50-C3D9-45BC-89A7-75ED05AA6FB2}" type="slidenum">
               <a:rPr lang="en-IN" smtClean="0"/>
               <a:t>‹#›</a:t>
             </a:fld>
@@ -2028,7 +2028,7 @@
     </p:spTree>
     <p:extLst>
       <p:ext uri="{BB962C8B-B14F-4D97-AF65-F5344CB8AC3E}">
-        <p14:creationId xmlns:p14="http://schemas.microsoft.com/office/powerpoint/2010/main" val="3591399558"/>
+        <p14:creationId xmlns:p14="http://schemas.microsoft.com/office/powerpoint/2010/main" val="2953708969"/>
       </p:ext>
     </p:extLst>
   </p:cSld>
@@ -2060,7 +2060,7 @@
           <p:cNvPr id="2" name="Vertical Title 1">
             <a:extLst>
               <a:ext uri="{FF2B5EF4-FFF2-40B4-BE49-F238E27FC236}">
-                <a16:creationId xmlns:a16="http://schemas.microsoft.com/office/drawing/2014/main" id="{EABA6965-CFE7-DD33-7E74-0DDB15AF16D4}"/>
+                <a16:creationId xmlns:a16="http://schemas.microsoft.com/office/drawing/2014/main" id="{14A96049-ED56-ECD9-F2AF-E7677E15BCAA}"/>
               </a:ext>
             </a:extLst>
           </p:cNvPr>
@@ -2094,7 +2094,7 @@
           <p:cNvPr id="3" name="Vertical Text Placeholder 2">
             <a:extLst>
               <a:ext uri="{FF2B5EF4-FFF2-40B4-BE49-F238E27FC236}">
-                <a16:creationId xmlns:a16="http://schemas.microsoft.com/office/drawing/2014/main" id="{29575060-2920-1FD4-5B2A-9D55ED3FDB5F}"/>
+                <a16:creationId xmlns:a16="http://schemas.microsoft.com/office/drawing/2014/main" id="{CF1D00DE-1A91-A46F-A57A-8937078E3E5D}"/>
               </a:ext>
             </a:extLst>
           </p:cNvPr>
@@ -2157,7 +2157,7 @@
           <p:cNvPr id="4" name="Date Placeholder 3">
             <a:extLst>
               <a:ext uri="{FF2B5EF4-FFF2-40B4-BE49-F238E27FC236}">
-                <a16:creationId xmlns:a16="http://schemas.microsoft.com/office/drawing/2014/main" id="{31A02AA9-204F-BE6B-4D12-6ECBD88DFDC4}"/>
+                <a16:creationId xmlns:a16="http://schemas.microsoft.com/office/drawing/2014/main" id="{8C2C823F-1766-9492-A6FE-5FCD0C9A3CCD}"/>
               </a:ext>
             </a:extLst>
           </p:cNvPr>
@@ -2173,7 +2173,7 @@
           <a:bodyPr/>
           <a:lstStyle/>
           <a:p>
-            <a:fld id="{41347811-5AC3-4474-A815-5801572B89F9}" type="datetimeFigureOut">
+            <a:fld id="{0DB4BE67-C782-407E-AB74-B6F0632D8A8C}" type="datetimeFigureOut">
               <a:rPr lang="en-IN" smtClean="0"/>
               <a:t>04-10-2026</a:t>
             </a:fld>
@@ -2186,7 +2186,7 @@
           <p:cNvPr id="5" name="Footer Placeholder 4">
             <a:extLst>
               <a:ext uri="{FF2B5EF4-FFF2-40B4-BE49-F238E27FC236}">
-                <a16:creationId xmlns:a16="http://schemas.microsoft.com/office/drawing/2014/main" id="{2E51196A-8E54-54B5-1924-880AAEBC557C}"/>
+                <a16:creationId xmlns:a16="http://schemas.microsoft.com/office/drawing/2014/main" id="{69BDE6E6-2E54-CE3C-7925-E066AB9D1B03}"/>
               </a:ext>
             </a:extLst>
           </p:cNvPr>
@@ -2211,7 +2211,7 @@
           <p:cNvPr id="6" name="Slide Number Placeholder 5">
             <a:extLst>
               <a:ext uri="{FF2B5EF4-FFF2-40B4-BE49-F238E27FC236}">
-                <a16:creationId xmlns:a16="http://schemas.microsoft.com/office/drawing/2014/main" id="{BCAE03EE-4FA3-919F-71D3-7D0E4C3FEDDD}"/>
+                <a16:creationId xmlns:a16="http://schemas.microsoft.com/office/drawing/2014/main" id="{81398E31-3151-D8EB-A6DA-749906A5388E}"/>
               </a:ext>
             </a:extLst>
           </p:cNvPr>
@@ -2227,7 +2227,7 @@
           <a:bodyPr/>
           <a:lstStyle/>
           <a:p>
-            <a:fld id="{2FC1135E-8EC1-4654-A988-9EF69C99888A}" type="slidenum">
+            <a:fld id="{DA029E50-C3D9-45BC-89A7-75ED05AA6FB2}" type="slidenum">
               <a:rPr lang="en-IN" smtClean="0"/>
               <a:t>‹#›</a:t>
             </a:fld>
@@ -2238,7 +2238,7 @@
     </p:spTree>
     <p:extLst>
       <p:ext uri="{BB962C8B-B14F-4D97-AF65-F5344CB8AC3E}">
-        <p14:creationId xmlns:p14="http://schemas.microsoft.com/office/powerpoint/2010/main" val="873032063"/>
+        <p14:creationId xmlns:p14="http://schemas.microsoft.com/office/powerpoint/2010/main" val="444740784"/>
       </p:ext>
     </p:extLst>
   </p:cSld>
@@ -2270,7 +2270,7 @@
           <p:cNvPr id="2" name="Title 1">
             <a:extLst>
               <a:ext uri="{FF2B5EF4-FFF2-40B4-BE49-F238E27FC236}">
-                <a16:creationId xmlns:a16="http://schemas.microsoft.com/office/drawing/2014/main" id="{4B585D81-2FF9-FD5A-444B-ED497BD9DBB3}"/>
+                <a16:creationId xmlns:a16="http://schemas.microsoft.com/office/drawing/2014/main" id="{19D2973A-8A6A-E05F-E156-1447F88E2C87}"/>
               </a:ext>
             </a:extLst>
           </p:cNvPr>
@@ -2299,7 +2299,7 @@
           <p:cNvPr id="3" name="Content Placeholder 2">
             <a:extLst>
               <a:ext uri="{FF2B5EF4-FFF2-40B4-BE49-F238E27FC236}">
-                <a16:creationId xmlns:a16="http://schemas.microsoft.com/office/drawing/2014/main" id="{AEE2F424-ABD2-6573-06AF-14C02F9078A3}"/>
+                <a16:creationId xmlns:a16="http://schemas.microsoft.com/office/drawing/2014/main" id="{8B272988-81CE-6E64-D8CC-51DC284091DA}"/>
               </a:ext>
             </a:extLst>
           </p:cNvPr>
@@ -2357,7 +2357,7 @@
           <p:cNvPr id="4" name="Date Placeholder 3">
             <a:extLst>
               <a:ext uri="{FF2B5EF4-FFF2-40B4-BE49-F238E27FC236}">
-                <a16:creationId xmlns:a16="http://schemas.microsoft.com/office/drawing/2014/main" id="{5CC261F0-E98A-A92A-732D-616B9C19B490}"/>
+                <a16:creationId xmlns:a16="http://schemas.microsoft.com/office/drawing/2014/main" id="{EE599E81-C86E-84A9-FB00-AB62DE54EF1B}"/>
               </a:ext>
             </a:extLst>
           </p:cNvPr>
@@ -2373,7 +2373,7 @@
           <a:bodyPr/>
           <a:lstStyle/>
           <a:p>
-            <a:fld id="{41347811-5AC3-4474-A815-5801572B89F9}" type="datetimeFigureOut">
+            <a:fld id="{0DB4BE67-C782-407E-AB74-B6F0632D8A8C}" type="datetimeFigureOut">
               <a:rPr lang="en-IN" smtClean="0"/>
               <a:t>04-10-2026</a:t>
             </a:fld>
@@ -2386,7 +2386,7 @@
           <p:cNvPr id="5" name="Footer Placeholder 4">
             <a:extLst>
               <a:ext uri="{FF2B5EF4-FFF2-40B4-BE49-F238E27FC236}">
-                <a16:creationId xmlns:a16="http://schemas.microsoft.com/office/drawing/2014/main" id="{619F3D1F-B0AE-E062-0700-3CF91BAD0D08}"/>
+                <a16:creationId xmlns:a16="http://schemas.microsoft.com/office/drawing/2014/main" id="{339E48BC-EEAD-D3A7-F85A-82C599B569F3}"/>
               </a:ext>
             </a:extLst>
           </p:cNvPr>
@@ -2411,7 +2411,7 @@
           <p:cNvPr id="6" name="Slide Number Placeholder 5">
             <a:extLst>
               <a:ext uri="{FF2B5EF4-FFF2-40B4-BE49-F238E27FC236}">
-                <a16:creationId xmlns:a16="http://schemas.microsoft.com/office/drawing/2014/main" id="{C8A23BB4-2363-7C77-F2A6-3C1CFA63CAB1}"/>
+                <a16:creationId xmlns:a16="http://schemas.microsoft.com/office/drawing/2014/main" id="{96106712-0FEC-E8A2-3DD1-50AEC024393B}"/>
               </a:ext>
             </a:extLst>
           </p:cNvPr>
@@ -2427,7 +2427,7 @@
           <a:bodyPr/>
           <a:lstStyle/>
           <a:p>
-            <a:fld id="{2FC1135E-8EC1-4654-A988-9EF69C99888A}" type="slidenum">
+            <a:fld id="{DA029E50-C3D9-45BC-89A7-75ED05AA6FB2}" type="slidenum">
               <a:rPr lang="en-IN" smtClean="0"/>
               <a:t>‹#›</a:t>
             </a:fld>
@@ -2438,7 +2438,7 @@
     </p:spTree>
     <p:extLst>
       <p:ext uri="{BB962C8B-B14F-4D97-AF65-F5344CB8AC3E}">
-        <p14:creationId xmlns:p14="http://schemas.microsoft.com/office/powerpoint/2010/main" val="3258236220"/>
+        <p14:creationId xmlns:p14="http://schemas.microsoft.com/office/powerpoint/2010/main" val="537211858"/>
       </p:ext>
     </p:extLst>
   </p:cSld>
@@ -2470,7 +2470,7 @@
           <p:cNvPr id="2" name="Title 1">
             <a:extLst>
               <a:ext uri="{FF2B5EF4-FFF2-40B4-BE49-F238E27FC236}">
-                <a16:creationId xmlns:a16="http://schemas.microsoft.com/office/drawing/2014/main" id="{15E83862-0086-D3DD-07DD-1BB685DD8367}"/>
+                <a16:creationId xmlns:a16="http://schemas.microsoft.com/office/drawing/2014/main" id="{AC7E372A-6688-2420-741D-ECE3BA596DDD}"/>
               </a:ext>
             </a:extLst>
           </p:cNvPr>
@@ -2508,7 +2508,7 @@
           <p:cNvPr id="3" name="Text Placeholder 2">
             <a:extLst>
               <a:ext uri="{FF2B5EF4-FFF2-40B4-BE49-F238E27FC236}">
-                <a16:creationId xmlns:a16="http://schemas.microsoft.com/office/drawing/2014/main" id="{3EB5F3C0-E171-B351-BCE8-090B617A0CF1}"/>
+                <a16:creationId xmlns:a16="http://schemas.microsoft.com/office/drawing/2014/main" id="{C56A1266-8961-1EAC-033B-7921CC7D4B85}"/>
               </a:ext>
             </a:extLst>
           </p:cNvPr>
@@ -2633,7 +2633,7 @@
           <p:cNvPr id="4" name="Date Placeholder 3">
             <a:extLst>
               <a:ext uri="{FF2B5EF4-FFF2-40B4-BE49-F238E27FC236}">
-                <a16:creationId xmlns:a16="http://schemas.microsoft.com/office/drawing/2014/main" id="{EAD46226-7CE6-D816-9B2D-FB9C762DECC0}"/>
+                <a16:creationId xmlns:a16="http://schemas.microsoft.com/office/drawing/2014/main" id="{98E69785-9EEC-412A-452C-641CDD8F676D}"/>
               </a:ext>
             </a:extLst>
           </p:cNvPr>
@@ -2649,7 +2649,7 @@
           <a:bodyPr/>
           <a:lstStyle/>
           <a:p>
-            <a:fld id="{41347811-5AC3-4474-A815-5801572B89F9}" type="datetimeFigureOut">
+            <a:fld id="{0DB4BE67-C782-407E-AB74-B6F0632D8A8C}" type="datetimeFigureOut">
               <a:rPr lang="en-IN" smtClean="0"/>
               <a:t>04-10-2026</a:t>
             </a:fld>
@@ -2662,7 +2662,7 @@
           <p:cNvPr id="5" name="Footer Placeholder 4">
             <a:extLst>
               <a:ext uri="{FF2B5EF4-FFF2-40B4-BE49-F238E27FC236}">
-                <a16:creationId xmlns:a16="http://schemas.microsoft.com/office/drawing/2014/main" id="{84EB5893-3D0B-86F2-D4D5-B835BF94BF8A}"/>
+                <a16:creationId xmlns:a16="http://schemas.microsoft.com/office/drawing/2014/main" id="{44908464-9906-0022-CA4E-A159AA311809}"/>
               </a:ext>
             </a:extLst>
           </p:cNvPr>
@@ -2687,7 +2687,7 @@
           <p:cNvPr id="6" name="Slide Number Placeholder 5">
             <a:extLst>
               <a:ext uri="{FF2B5EF4-FFF2-40B4-BE49-F238E27FC236}">
-                <a16:creationId xmlns:a16="http://schemas.microsoft.com/office/drawing/2014/main" id="{5AEB8CBA-6444-034E-6E62-D81B7C6614FD}"/>
+                <a16:creationId xmlns:a16="http://schemas.microsoft.com/office/drawing/2014/main" id="{8377D090-2E66-37F1-9593-C18948A96B7A}"/>
               </a:ext>
             </a:extLst>
           </p:cNvPr>
@@ -2703,7 +2703,7 @@
           <a:bodyPr/>
           <a:lstStyle/>
           <a:p>
-            <a:fld id="{2FC1135E-8EC1-4654-A988-9EF69C99888A}" type="slidenum">
+            <a:fld id="{DA029E50-C3D9-45BC-89A7-75ED05AA6FB2}" type="slidenum">
               <a:rPr lang="en-IN" smtClean="0"/>
               <a:t>‹#›</a:t>
             </a:fld>
@@ -2714,7 +2714,7 @@
     </p:spTree>
     <p:extLst>
       <p:ext uri="{BB962C8B-B14F-4D97-AF65-F5344CB8AC3E}">
-        <p14:creationId xmlns:p14="http://schemas.microsoft.com/office/powerpoint/2010/main" val="3607161111"/>
+        <p14:creationId xmlns:p14="http://schemas.microsoft.com/office/powerpoint/2010/main" val="561324382"/>
       </p:ext>
     </p:extLst>
   </p:cSld>
@@ -2746,7 +2746,7 @@
           <p:cNvPr id="2" name="Title 1">
             <a:extLst>
               <a:ext uri="{FF2B5EF4-FFF2-40B4-BE49-F238E27FC236}">
-                <a16:creationId xmlns:a16="http://schemas.microsoft.com/office/drawing/2014/main" id="{2369425E-8D9C-36E8-1629-C7D9F152EE44}"/>
+                <a16:creationId xmlns:a16="http://schemas.microsoft.com/office/drawing/2014/main" id="{F83A259D-72E7-1374-1313-1DBD2FE88B45}"/>
               </a:ext>
             </a:extLst>
           </p:cNvPr>
@@ -2775,7 +2775,7 @@
           <p:cNvPr id="3" name="Content Placeholder 2">
             <a:extLst>
               <a:ext uri="{FF2B5EF4-FFF2-40B4-BE49-F238E27FC236}">
-                <a16:creationId xmlns:a16="http://schemas.microsoft.com/office/drawing/2014/main" id="{D0C93E0B-36A4-18F5-3FA2-0FF0DD394E94}"/>
+                <a16:creationId xmlns:a16="http://schemas.microsoft.com/office/drawing/2014/main" id="{BD4C52F8-C002-5385-24FD-8FC2FEE8EDC0}"/>
               </a:ext>
             </a:extLst>
           </p:cNvPr>
@@ -2838,7 +2838,7 @@
           <p:cNvPr id="4" name="Content Placeholder 3">
             <a:extLst>
               <a:ext uri="{FF2B5EF4-FFF2-40B4-BE49-F238E27FC236}">
-                <a16:creationId xmlns:a16="http://schemas.microsoft.com/office/drawing/2014/main" id="{4807BF84-14D9-2FA7-3B81-CF1DC68FED6B}"/>
+                <a16:creationId xmlns:a16="http://schemas.microsoft.com/office/drawing/2014/main" id="{6D63BB2B-FF38-94F2-0F93-60B19A893873}"/>
               </a:ext>
             </a:extLst>
           </p:cNvPr>
@@ -2901,7 +2901,7 @@
           <p:cNvPr id="5" name="Date Placeholder 4">
             <a:extLst>
               <a:ext uri="{FF2B5EF4-FFF2-40B4-BE49-F238E27FC236}">
-                <a16:creationId xmlns:a16="http://schemas.microsoft.com/office/drawing/2014/main" id="{75B9615D-6B90-6E3C-3F29-072A6853BE5D}"/>
+                <a16:creationId xmlns:a16="http://schemas.microsoft.com/office/drawing/2014/main" id="{3D932FC2-E37A-88D2-2016-51E53D6260F3}"/>
               </a:ext>
             </a:extLst>
           </p:cNvPr>
@@ -2917,7 +2917,7 @@
           <a:bodyPr/>
           <a:lstStyle/>
           <a:p>
-            <a:fld id="{41347811-5AC3-4474-A815-5801572B89F9}" type="datetimeFigureOut">
+            <a:fld id="{0DB4BE67-C782-407E-AB74-B6F0632D8A8C}" type="datetimeFigureOut">
               <a:rPr lang="en-IN" smtClean="0"/>
               <a:t>04-10-2026</a:t>
             </a:fld>
@@ -2930,7 +2930,7 @@
           <p:cNvPr id="6" name="Footer Placeholder 5">
             <a:extLst>
               <a:ext uri="{FF2B5EF4-FFF2-40B4-BE49-F238E27FC236}">
-                <a16:creationId xmlns:a16="http://schemas.microsoft.com/office/drawing/2014/main" id="{1941FF92-B662-C916-8DCA-531D5D158C89}"/>
+                <a16:creationId xmlns:a16="http://schemas.microsoft.com/office/drawing/2014/main" id="{7DB59931-EC71-F06F-2AFB-D9B81461EFF3}"/>
               </a:ext>
             </a:extLst>
           </p:cNvPr>
@@ -2955,7 +2955,7 @@
           <p:cNvPr id="7" name="Slide Number Placeholder 6">
             <a:extLst>
               <a:ext uri="{FF2B5EF4-FFF2-40B4-BE49-F238E27FC236}">
-                <a16:creationId xmlns:a16="http://schemas.microsoft.com/office/drawing/2014/main" id="{424E53C5-CAD6-55E6-7944-0E81E5BE115D}"/>
+                <a16:creationId xmlns:a16="http://schemas.microsoft.com/office/drawing/2014/main" id="{B8F14B47-69F5-56E4-A789-7E50A9CF5B81}"/>
               </a:ext>
             </a:extLst>
           </p:cNvPr>
@@ -2971,7 +2971,7 @@
           <a:bodyPr/>
           <a:lstStyle/>
           <a:p>
-            <a:fld id="{2FC1135E-8EC1-4654-A988-9EF69C99888A}" type="slidenum">
+            <a:fld id="{DA029E50-C3D9-45BC-89A7-75ED05AA6FB2}" type="slidenum">
               <a:rPr lang="en-IN" smtClean="0"/>
               <a:t>‹#›</a:t>
             </a:fld>
@@ -2982,7 +2982,7 @@
     </p:spTree>
     <p:extLst>
       <p:ext uri="{BB962C8B-B14F-4D97-AF65-F5344CB8AC3E}">
-        <p14:creationId xmlns:p14="http://schemas.microsoft.com/office/powerpoint/2010/main" val="968656805"/>
+        <p14:creationId xmlns:p14="http://schemas.microsoft.com/office/powerpoint/2010/main" val="4232528299"/>
       </p:ext>
     </p:extLst>
   </p:cSld>
@@ -3014,7 +3014,7 @@
           <p:cNvPr id="2" name="Title 1">
             <a:extLst>
               <a:ext uri="{FF2B5EF4-FFF2-40B4-BE49-F238E27FC236}">
-                <a16:creationId xmlns:a16="http://schemas.microsoft.com/office/drawing/2014/main" id="{1DB8E6DE-CCA2-67FC-8019-1E742DA7671D}"/>
+                <a16:creationId xmlns:a16="http://schemas.microsoft.com/office/drawing/2014/main" id="{7FF95B38-58BE-0040-98AF-1EC3972A548F}"/>
               </a:ext>
             </a:extLst>
           </p:cNvPr>
@@ -3048,7 +3048,7 @@
           <p:cNvPr id="3" name="Text Placeholder 2">
             <a:extLst>
               <a:ext uri="{FF2B5EF4-FFF2-40B4-BE49-F238E27FC236}">
-                <a16:creationId xmlns:a16="http://schemas.microsoft.com/office/drawing/2014/main" id="{FF5B7BBD-4C85-B4FC-5D3F-F31CA716B38B}"/>
+                <a16:creationId xmlns:a16="http://schemas.microsoft.com/office/drawing/2014/main" id="{0CC51A2E-91D3-A466-0430-A72B2C60A158}"/>
               </a:ext>
             </a:extLst>
           </p:cNvPr>
@@ -3119,7 +3119,7 @@
           <p:cNvPr id="4" name="Content Placeholder 3">
             <a:extLst>
               <a:ext uri="{FF2B5EF4-FFF2-40B4-BE49-F238E27FC236}">
-                <a16:creationId xmlns:a16="http://schemas.microsoft.com/office/drawing/2014/main" id="{8E96EE1A-5CC5-6E8A-143F-0DF56B1098AB}"/>
+                <a16:creationId xmlns:a16="http://schemas.microsoft.com/office/drawing/2014/main" id="{C0E3F0BA-C559-0950-C95B-FDF2D5AF1661}"/>
               </a:ext>
             </a:extLst>
           </p:cNvPr>
@@ -3182,7 +3182,7 @@
           <p:cNvPr id="5" name="Text Placeholder 4">
             <a:extLst>
               <a:ext uri="{FF2B5EF4-FFF2-40B4-BE49-F238E27FC236}">
-                <a16:creationId xmlns:a16="http://schemas.microsoft.com/office/drawing/2014/main" id="{50C05498-3606-3540-CDAE-535784912300}"/>
+                <a16:creationId xmlns:a16="http://schemas.microsoft.com/office/drawing/2014/main" id="{FA70B16D-0F03-8829-206A-174A76A38FB3}"/>
               </a:ext>
             </a:extLst>
           </p:cNvPr>
@@ -3253,7 +3253,7 @@
           <p:cNvPr id="6" name="Content Placeholder 5">
             <a:extLst>
               <a:ext uri="{FF2B5EF4-FFF2-40B4-BE49-F238E27FC236}">
-                <a16:creationId xmlns:a16="http://schemas.microsoft.com/office/drawing/2014/main" id="{31959AF4-47C5-2CA8-D347-53EAAAABEE13}"/>
+                <a16:creationId xmlns:a16="http://schemas.microsoft.com/office/drawing/2014/main" id="{B808A705-9466-91DA-7008-C94B6418A4A4}"/>
               </a:ext>
             </a:extLst>
           </p:cNvPr>
@@ -3316,7 +3316,7 @@
           <p:cNvPr id="7" name="Date Placeholder 6">
             <a:extLst>
               <a:ext uri="{FF2B5EF4-FFF2-40B4-BE49-F238E27FC236}">
-                <a16:creationId xmlns:a16="http://schemas.microsoft.com/office/drawing/2014/main" id="{B0D81860-05FE-4F72-03F6-A8024E2A6228}"/>
+                <a16:creationId xmlns:a16="http://schemas.microsoft.com/office/drawing/2014/main" id="{EE0F5C1A-7E3A-83AD-EF79-C946B6EB6115}"/>
               </a:ext>
             </a:extLst>
           </p:cNvPr>
@@ -3332,7 +3332,7 @@
           <a:bodyPr/>
           <a:lstStyle/>
           <a:p>
-            <a:fld id="{41347811-5AC3-4474-A815-5801572B89F9}" type="datetimeFigureOut">
+            <a:fld id="{0DB4BE67-C782-407E-AB74-B6F0632D8A8C}" type="datetimeFigureOut">
               <a:rPr lang="en-IN" smtClean="0"/>
               <a:t>04-10-2026</a:t>
             </a:fld>
@@ -3345,7 +3345,7 @@
           <p:cNvPr id="8" name="Footer Placeholder 7">
             <a:extLst>
               <a:ext uri="{FF2B5EF4-FFF2-40B4-BE49-F238E27FC236}">
-                <a16:creationId xmlns:a16="http://schemas.microsoft.com/office/drawing/2014/main" id="{7B5367C7-69DB-062F-4503-1054732FA481}"/>
+                <a16:creationId xmlns:a16="http://schemas.microsoft.com/office/drawing/2014/main" id="{06A964E7-CD8A-48B0-3025-4029135E4E1E}"/>
               </a:ext>
             </a:extLst>
           </p:cNvPr>
@@ -3370,7 +3370,7 @@
           <p:cNvPr id="9" name="Slide Number Placeholder 8">
             <a:extLst>
               <a:ext uri="{FF2B5EF4-FFF2-40B4-BE49-F238E27FC236}">
-                <a16:creationId xmlns:a16="http://schemas.microsoft.com/office/drawing/2014/main" id="{C7F2851E-B1BD-5140-952C-00F7D105E8C2}"/>
+                <a16:creationId xmlns:a16="http://schemas.microsoft.com/office/drawing/2014/main" id="{93BA9BCF-3C1C-6CCB-5A7C-1192F7A0A56B}"/>
               </a:ext>
             </a:extLst>
           </p:cNvPr>
@@ -3386,7 +3386,7 @@
           <a:bodyPr/>
           <a:lstStyle/>
           <a:p>
-            <a:fld id="{2FC1135E-8EC1-4654-A988-9EF69C99888A}" type="slidenum">
+            <a:fld id="{DA029E50-C3D9-45BC-89A7-75ED05AA6FB2}" type="slidenum">
               <a:rPr lang="en-IN" smtClean="0"/>
               <a:t>‹#›</a:t>
             </a:fld>
@@ -3397,7 +3397,7 @@
     </p:spTree>
     <p:extLst>
       <p:ext uri="{BB962C8B-B14F-4D97-AF65-F5344CB8AC3E}">
-        <p14:creationId xmlns:p14="http://schemas.microsoft.com/office/powerpoint/2010/main" val="1284017639"/>
+        <p14:creationId xmlns:p14="http://schemas.microsoft.com/office/powerpoint/2010/main" val="665538893"/>
       </p:ext>
     </p:extLst>
   </p:cSld>
@@ -3429,7 +3429,7 @@
           <p:cNvPr id="2" name="Title 1">
             <a:extLst>
               <a:ext uri="{FF2B5EF4-FFF2-40B4-BE49-F238E27FC236}">
-                <a16:creationId xmlns:a16="http://schemas.microsoft.com/office/drawing/2014/main" id="{CE590160-58E3-9906-5E63-0A1A08230326}"/>
+                <a16:creationId xmlns:a16="http://schemas.microsoft.com/office/drawing/2014/main" id="{00642F74-2B0C-0F50-9D2D-E356A0CEB5FD}"/>
               </a:ext>
             </a:extLst>
           </p:cNvPr>
@@ -3458,7 +3458,7 @@
           <p:cNvPr id="3" name="Date Placeholder 2">
             <a:extLst>
               <a:ext uri="{FF2B5EF4-FFF2-40B4-BE49-F238E27FC236}">
-                <a16:creationId xmlns:a16="http://schemas.microsoft.com/office/drawing/2014/main" id="{551BCC40-FB37-FFFB-D8F0-04CA31F239E8}"/>
+                <a16:creationId xmlns:a16="http://schemas.microsoft.com/office/drawing/2014/main" id="{7434B5B2-C77E-AFF7-3BF7-9C86CA7F904A}"/>
               </a:ext>
             </a:extLst>
           </p:cNvPr>
@@ -3474,7 +3474,7 @@
           <a:bodyPr/>
           <a:lstStyle/>
           <a:p>
-            <a:fld id="{41347811-5AC3-4474-A815-5801572B89F9}" type="datetimeFigureOut">
+            <a:fld id="{0DB4BE67-C782-407E-AB74-B6F0632D8A8C}" type="datetimeFigureOut">
               <a:rPr lang="en-IN" smtClean="0"/>
               <a:t>04-10-2026</a:t>
             </a:fld>
@@ -3487,7 +3487,7 @@
           <p:cNvPr id="4" name="Footer Placeholder 3">
             <a:extLst>
               <a:ext uri="{FF2B5EF4-FFF2-40B4-BE49-F238E27FC236}">
-                <a16:creationId xmlns:a16="http://schemas.microsoft.com/office/drawing/2014/main" id="{E190E818-6ADB-4CC6-38BA-66B7D6E02BBF}"/>
+                <a16:creationId xmlns:a16="http://schemas.microsoft.com/office/drawing/2014/main" id="{F3A444BA-4DDC-80B7-90CE-99C29740B329}"/>
               </a:ext>
             </a:extLst>
           </p:cNvPr>
@@ -3512,7 +3512,7 @@
           <p:cNvPr id="5" name="Slide Number Placeholder 4">
             <a:extLst>
               <a:ext uri="{FF2B5EF4-FFF2-40B4-BE49-F238E27FC236}">
-                <a16:creationId xmlns:a16="http://schemas.microsoft.com/office/drawing/2014/main" id="{DCA77D26-1C64-5573-A4EE-30D930806F7D}"/>
+                <a16:creationId xmlns:a16="http://schemas.microsoft.com/office/drawing/2014/main" id="{DEB653F8-D82B-6F44-D3A5-012A6F08D2DC}"/>
               </a:ext>
             </a:extLst>
           </p:cNvPr>
@@ -3528,7 +3528,7 @@
           <a:bodyPr/>
           <a:lstStyle/>
           <a:p>
-            <a:fld id="{2FC1135E-8EC1-4654-A988-9EF69C99888A}" type="slidenum">
+            <a:fld id="{DA029E50-C3D9-45BC-89A7-75ED05AA6FB2}" type="slidenum">
               <a:rPr lang="en-IN" smtClean="0"/>
               <a:t>‹#›</a:t>
             </a:fld>
@@ -3539,7 +3539,7 @@
     </p:spTree>
     <p:extLst>
       <p:ext uri="{BB962C8B-B14F-4D97-AF65-F5344CB8AC3E}">
-        <p14:creationId xmlns:p14="http://schemas.microsoft.com/office/powerpoint/2010/main" val="3513978737"/>
+        <p14:creationId xmlns:p14="http://schemas.microsoft.com/office/powerpoint/2010/main" val="1299961347"/>
       </p:ext>
     </p:extLst>
   </p:cSld>
@@ -3571,7 +3571,7 @@
           <p:cNvPr id="2" name="Date Placeholder 1">
             <a:extLst>
               <a:ext uri="{FF2B5EF4-FFF2-40B4-BE49-F238E27FC236}">
-                <a16:creationId xmlns:a16="http://schemas.microsoft.com/office/drawing/2014/main" id="{323B04FE-07E0-0577-D858-365E59C645F5}"/>
+                <a16:creationId xmlns:a16="http://schemas.microsoft.com/office/drawing/2014/main" id="{66A6D832-54F7-94DB-9B3C-1BBD753092D5}"/>
               </a:ext>
             </a:extLst>
           </p:cNvPr>
@@ -3587,7 +3587,7 @@
           <a:bodyPr/>
           <a:lstStyle/>
           <a:p>
-            <a:fld id="{41347811-5AC3-4474-A815-5801572B89F9}" type="datetimeFigureOut">
+            <a:fld id="{0DB4BE67-C782-407E-AB74-B6F0632D8A8C}" type="datetimeFigureOut">
               <a:rPr lang="en-IN" smtClean="0"/>
               <a:t>04-10-2026</a:t>
             </a:fld>
@@ -3600,7 +3600,7 @@
           <p:cNvPr id="3" name="Footer Placeholder 2">
             <a:extLst>
               <a:ext uri="{FF2B5EF4-FFF2-40B4-BE49-F238E27FC236}">
-                <a16:creationId xmlns:a16="http://schemas.microsoft.com/office/drawing/2014/main" id="{AC0802A8-1358-E484-C163-088FF0A34530}"/>
+                <a16:creationId xmlns:a16="http://schemas.microsoft.com/office/drawing/2014/main" id="{9509A3AF-AA7C-1FB9-A5DB-B507DFB3313D}"/>
               </a:ext>
             </a:extLst>
           </p:cNvPr>
@@ -3625,7 +3625,7 @@
           <p:cNvPr id="4" name="Slide Number Placeholder 3">
             <a:extLst>
               <a:ext uri="{FF2B5EF4-FFF2-40B4-BE49-F238E27FC236}">
-                <a16:creationId xmlns:a16="http://schemas.microsoft.com/office/drawing/2014/main" id="{2AD5C99F-0253-25C0-3113-EA58FA5D1231}"/>
+                <a16:creationId xmlns:a16="http://schemas.microsoft.com/office/drawing/2014/main" id="{2BE38480-7796-E085-B3C5-6155645EF248}"/>
               </a:ext>
             </a:extLst>
           </p:cNvPr>
@@ -3641,7 +3641,7 @@
           <a:bodyPr/>
           <a:lstStyle/>
           <a:p>
-            <a:fld id="{2FC1135E-8EC1-4654-A988-9EF69C99888A}" type="slidenum">
+            <a:fld id="{DA029E50-C3D9-45BC-89A7-75ED05AA6FB2}" type="slidenum">
               <a:rPr lang="en-IN" smtClean="0"/>
               <a:t>‹#›</a:t>
             </a:fld>
@@ -3652,7 +3652,7 @@
     </p:spTree>
     <p:extLst>
       <p:ext uri="{BB962C8B-B14F-4D97-AF65-F5344CB8AC3E}">
-        <p14:creationId xmlns:p14="http://schemas.microsoft.com/office/powerpoint/2010/main" val="2813948768"/>
+        <p14:creationId xmlns:p14="http://schemas.microsoft.com/office/powerpoint/2010/main" val="3871086278"/>
       </p:ext>
     </p:extLst>
   </p:cSld>
@@ -3684,7 +3684,7 @@
           <p:cNvPr id="2" name="Title 1">
             <a:extLst>
               <a:ext uri="{FF2B5EF4-FFF2-40B4-BE49-F238E27FC236}">
-                <a16:creationId xmlns:a16="http://schemas.microsoft.com/office/drawing/2014/main" id="{94785F1B-0368-E8D8-A6C4-137FCC645706}"/>
+                <a16:creationId xmlns:a16="http://schemas.microsoft.com/office/drawing/2014/main" id="{1B830B59-5EB1-A53A-EE4C-16D83D5A0664}"/>
               </a:ext>
             </a:extLst>
           </p:cNvPr>
@@ -3722,7 +3722,7 @@
           <p:cNvPr id="3" name="Content Placeholder 2">
             <a:extLst>
               <a:ext uri="{FF2B5EF4-FFF2-40B4-BE49-F238E27FC236}">
-                <a16:creationId xmlns:a16="http://schemas.microsoft.com/office/drawing/2014/main" id="{8BCE580C-91EC-7809-F77B-90E073ABB211}"/>
+                <a16:creationId xmlns:a16="http://schemas.microsoft.com/office/drawing/2014/main" id="{6B88CF74-3A00-326C-259D-B15F1C4A4105}"/>
               </a:ext>
             </a:extLst>
           </p:cNvPr>
@@ -3813,7 +3813,7 @@
           <p:cNvPr id="4" name="Text Placeholder 3">
             <a:extLst>
               <a:ext uri="{FF2B5EF4-FFF2-40B4-BE49-F238E27FC236}">
-                <a16:creationId xmlns:a16="http://schemas.microsoft.com/office/drawing/2014/main" id="{8801CE5C-0CAD-6FAB-E236-C242B6823715}"/>
+                <a16:creationId xmlns:a16="http://schemas.microsoft.com/office/drawing/2014/main" id="{E38A62D6-4277-EB37-C3E0-A88D09A8FB6E}"/>
               </a:ext>
             </a:extLst>
           </p:cNvPr>
@@ -3884,7 +3884,7 @@
           <p:cNvPr id="5" name="Date Placeholder 4">
             <a:extLst>
               <a:ext uri="{FF2B5EF4-FFF2-40B4-BE49-F238E27FC236}">
-                <a16:creationId xmlns:a16="http://schemas.microsoft.com/office/drawing/2014/main" id="{65315779-59FF-93F3-F483-A1F0717C8DEF}"/>
+                <a16:creationId xmlns:a16="http://schemas.microsoft.com/office/drawing/2014/main" id="{2F9B742D-D8A1-6827-E9B3-D04B77E9EC6F}"/>
               </a:ext>
             </a:extLst>
           </p:cNvPr>
@@ -3900,7 +3900,7 @@
           <a:bodyPr/>
           <a:lstStyle/>
           <a:p>
-            <a:fld id="{41347811-5AC3-4474-A815-5801572B89F9}" type="datetimeFigureOut">
+            <a:fld id="{0DB4BE67-C782-407E-AB74-B6F0632D8A8C}" type="datetimeFigureOut">
               <a:rPr lang="en-IN" smtClean="0"/>
               <a:t>04-10-2026</a:t>
             </a:fld>
@@ -3913,7 +3913,7 @@
           <p:cNvPr id="6" name="Footer Placeholder 5">
             <a:extLst>
               <a:ext uri="{FF2B5EF4-FFF2-40B4-BE49-F238E27FC236}">
-                <a16:creationId xmlns:a16="http://schemas.microsoft.com/office/drawing/2014/main" id="{33C52277-2E7B-9FEF-3B22-202A933FB555}"/>
+                <a16:creationId xmlns:a16="http://schemas.microsoft.com/office/drawing/2014/main" id="{D092A2DF-9CB0-B4B9-A2AA-B959AF7C4E9A}"/>
               </a:ext>
             </a:extLst>
           </p:cNvPr>
@@ -3938,7 +3938,7 @@
           <p:cNvPr id="7" name="Slide Number Placeholder 6">
             <a:extLst>
               <a:ext uri="{FF2B5EF4-FFF2-40B4-BE49-F238E27FC236}">
-                <a16:creationId xmlns:a16="http://schemas.microsoft.com/office/drawing/2014/main" id="{C95EBA06-489A-78A9-8621-1B9ADBAF8F92}"/>
+                <a16:creationId xmlns:a16="http://schemas.microsoft.com/office/drawing/2014/main" id="{077403B4-54E6-C432-258D-49BEE1BC5901}"/>
               </a:ext>
             </a:extLst>
           </p:cNvPr>
@@ -3954,7 +3954,7 @@
           <a:bodyPr/>
           <a:lstStyle/>
           <a:p>
-            <a:fld id="{2FC1135E-8EC1-4654-A988-9EF69C99888A}" type="slidenum">
+            <a:fld id="{DA029E50-C3D9-45BC-89A7-75ED05AA6FB2}" type="slidenum">
               <a:rPr lang="en-IN" smtClean="0"/>
               <a:t>‹#›</a:t>
             </a:fld>
@@ -3965,7 +3965,7 @@
     </p:spTree>
     <p:extLst>
       <p:ext uri="{BB962C8B-B14F-4D97-AF65-F5344CB8AC3E}">
-        <p14:creationId xmlns:p14="http://schemas.microsoft.com/office/powerpoint/2010/main" val="2811937942"/>
+        <p14:creationId xmlns:p14="http://schemas.microsoft.com/office/powerpoint/2010/main" val="3777522601"/>
       </p:ext>
     </p:extLst>
   </p:cSld>
@@ -3997,7 +3997,7 @@
           <p:cNvPr id="2" name="Title 1">
             <a:extLst>
               <a:ext uri="{FF2B5EF4-FFF2-40B4-BE49-F238E27FC236}">
-                <a16:creationId xmlns:a16="http://schemas.microsoft.com/office/drawing/2014/main" id="{EA2F5271-BFCD-9468-D62E-0893579D7CD4}"/>
+                <a16:creationId xmlns:a16="http://schemas.microsoft.com/office/drawing/2014/main" id="{AA2B694C-446E-44E6-81D5-23F4423F9227}"/>
               </a:ext>
             </a:extLst>
           </p:cNvPr>
@@ -4035,7 +4035,7 @@
           <p:cNvPr id="3" name="Picture Placeholder 2">
             <a:extLst>
               <a:ext uri="{FF2B5EF4-FFF2-40B4-BE49-F238E27FC236}">
-                <a16:creationId xmlns:a16="http://schemas.microsoft.com/office/drawing/2014/main" id="{887189D4-4F8D-DF78-4A6E-1BCBE2B6B882}"/>
+                <a16:creationId xmlns:a16="http://schemas.microsoft.com/office/drawing/2014/main" id="{55952AD4-FB34-924D-D7CB-8650B8B461D2}"/>
               </a:ext>
             </a:extLst>
           </p:cNvPr>
@@ -4102,7 +4102,7 @@
           <p:cNvPr id="4" name="Text Placeholder 3">
             <a:extLst>
               <a:ext uri="{FF2B5EF4-FFF2-40B4-BE49-F238E27FC236}">
-                <a16:creationId xmlns:a16="http://schemas.microsoft.com/office/drawing/2014/main" id="{5912FAF0-AAAA-6A78-7E0E-0A299463A753}"/>
+                <a16:creationId xmlns:a16="http://schemas.microsoft.com/office/drawing/2014/main" id="{F8E0D5AF-06D1-AE4F-5331-260AD33F399F}"/>
               </a:ext>
             </a:extLst>
           </p:cNvPr>
@@ -4173,7 +4173,7 @@
           <p:cNvPr id="5" name="Date Placeholder 4">
             <a:extLst>
               <a:ext uri="{FF2B5EF4-FFF2-40B4-BE49-F238E27FC236}">
-                <a16:creationId xmlns:a16="http://schemas.microsoft.com/office/drawing/2014/main" id="{54BEE92B-E5D0-D351-96C9-DD090471F26F}"/>
+                <a16:creationId xmlns:a16="http://schemas.microsoft.com/office/drawing/2014/main" id="{3BEB70BC-A489-6B5D-F1AE-5F47254C6043}"/>
               </a:ext>
             </a:extLst>
           </p:cNvPr>
@@ -4189,7 +4189,7 @@
           <a:bodyPr/>
           <a:lstStyle/>
           <a:p>
-            <a:fld id="{41347811-5AC3-4474-A815-5801572B89F9}" type="datetimeFigureOut">
+            <a:fld id="{0DB4BE67-C782-407E-AB74-B6F0632D8A8C}" type="datetimeFigureOut">
               <a:rPr lang="en-IN" smtClean="0"/>
               <a:t>04-10-2026</a:t>
             </a:fld>
@@ -4202,7 +4202,7 @@
           <p:cNvPr id="6" name="Footer Placeholder 5">
             <a:extLst>
               <a:ext uri="{FF2B5EF4-FFF2-40B4-BE49-F238E27FC236}">
-                <a16:creationId xmlns:a16="http://schemas.microsoft.com/office/drawing/2014/main" id="{9C9F6FC2-7FB6-BC53-22C1-9173B1F9DFCE}"/>
+                <a16:creationId xmlns:a16="http://schemas.microsoft.com/office/drawing/2014/main" id="{98F6A52D-D433-D613-2A16-141B63E0B649}"/>
               </a:ext>
             </a:extLst>
           </p:cNvPr>
@@ -4227,7 +4227,7 @@
           <p:cNvPr id="7" name="Slide Number Placeholder 6">
             <a:extLst>
               <a:ext uri="{FF2B5EF4-FFF2-40B4-BE49-F238E27FC236}">
-                <a16:creationId xmlns:a16="http://schemas.microsoft.com/office/drawing/2014/main" id="{EEBF4FE6-B2C5-E834-9BCF-FE9997804B00}"/>
+                <a16:creationId xmlns:a16="http://schemas.microsoft.com/office/drawing/2014/main" id="{A7BA6B23-9C48-74E5-C5D3-06A8C6166A9E}"/>
               </a:ext>
             </a:extLst>
           </p:cNvPr>
@@ -4243,7 +4243,7 @@
           <a:bodyPr/>
           <a:lstStyle/>
           <a:p>
-            <a:fld id="{2FC1135E-8EC1-4654-A988-9EF69C99888A}" type="slidenum">
+            <a:fld id="{DA029E50-C3D9-45BC-89A7-75ED05AA6FB2}" type="slidenum">
               <a:rPr lang="en-IN" smtClean="0"/>
               <a:t>‹#›</a:t>
             </a:fld>
@@ -4254,7 +4254,7 @@
     </p:spTree>
     <p:extLst>
       <p:ext uri="{BB962C8B-B14F-4D97-AF65-F5344CB8AC3E}">
-        <p14:creationId xmlns:p14="http://schemas.microsoft.com/office/powerpoint/2010/main" val="1923040988"/>
+        <p14:creationId xmlns:p14="http://schemas.microsoft.com/office/powerpoint/2010/main" val="3087580295"/>
       </p:ext>
     </p:extLst>
   </p:cSld>
@@ -4291,7 +4291,7 @@
           <p:cNvPr id="2" name="Title Placeholder 1">
             <a:extLst>
               <a:ext uri="{FF2B5EF4-FFF2-40B4-BE49-F238E27FC236}">
-                <a16:creationId xmlns:a16="http://schemas.microsoft.com/office/drawing/2014/main" id="{273BD840-29D8-8CC2-A35D-68870EEA148E}"/>
+                <a16:creationId xmlns:a16="http://schemas.microsoft.com/office/drawing/2014/main" id="{AD2C4E93-59CB-244F-A2B6-8195605F2ED3}"/>
               </a:ext>
             </a:extLst>
           </p:cNvPr>
@@ -4330,7 +4330,7 @@
           <p:cNvPr id="3" name="Text Placeholder 2">
             <a:extLst>
               <a:ext uri="{FF2B5EF4-FFF2-40B4-BE49-F238E27FC236}">
-                <a16:creationId xmlns:a16="http://schemas.microsoft.com/office/drawing/2014/main" id="{503A1BC9-1689-940A-F6F9-350682F663E9}"/>
+                <a16:creationId xmlns:a16="http://schemas.microsoft.com/office/drawing/2014/main" id="{9542EB01-831E-B7DB-5E84-6E3F287F7223}"/>
               </a:ext>
             </a:extLst>
           </p:cNvPr>
@@ -4398,7 +4398,7 @@
           <p:cNvPr id="4" name="Date Placeholder 3">
             <a:extLst>
               <a:ext uri="{FF2B5EF4-FFF2-40B4-BE49-F238E27FC236}">
-                <a16:creationId xmlns:a16="http://schemas.microsoft.com/office/drawing/2014/main" id="{E8FE6C82-C497-6671-FE79-A97DEBA15B03}"/>
+                <a16:creationId xmlns:a16="http://schemas.microsoft.com/office/drawing/2014/main" id="{2B76BE67-3BE6-E4B4-2E60-2CB86539560C}"/>
               </a:ext>
             </a:extLst>
           </p:cNvPr>
@@ -4432,7 +4432,7 @@
             </a:lvl1pPr>
           </a:lstStyle>
           <a:p>
-            <a:fld id="{41347811-5AC3-4474-A815-5801572B89F9}" type="datetimeFigureOut">
+            <a:fld id="{0DB4BE67-C782-407E-AB74-B6F0632D8A8C}" type="datetimeFigureOut">
               <a:rPr lang="en-IN" smtClean="0"/>
               <a:t>04-10-2026</a:t>
             </a:fld>
@@ -4445,7 +4445,7 @@
           <p:cNvPr id="5" name="Footer Placeholder 4">
             <a:extLst>
               <a:ext uri="{FF2B5EF4-FFF2-40B4-BE49-F238E27FC236}">
-                <a16:creationId xmlns:a16="http://schemas.microsoft.com/office/drawing/2014/main" id="{E749C3B8-EEAC-017C-5564-CAE22F803617}"/>
+                <a16:creationId xmlns:a16="http://schemas.microsoft.com/office/drawing/2014/main" id="{5FAEA72C-0C79-EE91-D37F-2C561FD17FA7}"/>
               </a:ext>
             </a:extLst>
           </p:cNvPr>
@@ -4488,7 +4488,7 @@
           <p:cNvPr id="6" name="Slide Number Placeholder 5">
             <a:extLst>
               <a:ext uri="{FF2B5EF4-FFF2-40B4-BE49-F238E27FC236}">
-                <a16:creationId xmlns:a16="http://schemas.microsoft.com/office/drawing/2014/main" id="{B433D129-C056-E1CF-8267-DAA5CA01EBCF}"/>
+                <a16:creationId xmlns:a16="http://schemas.microsoft.com/office/drawing/2014/main" id="{28CDF12F-B05A-1090-3772-D5149A04DAF6}"/>
               </a:ext>
             </a:extLst>
           </p:cNvPr>
@@ -4522,7 +4522,7 @@
             </a:lvl1pPr>
           </a:lstStyle>
           <a:p>
-            <a:fld id="{2FC1135E-8EC1-4654-A988-9EF69C99888A}" type="slidenum">
+            <a:fld id="{DA029E50-C3D9-45BC-89A7-75ED05AA6FB2}" type="slidenum">
               <a:rPr lang="en-IN" smtClean="0"/>
               <a:t>‹#›</a:t>
             </a:fld>
@@ -4533,7 +4533,7 @@
     </p:spTree>
     <p:extLst>
       <p:ext uri="{BB962C8B-B14F-4D97-AF65-F5344CB8AC3E}">
-        <p14:creationId xmlns:p14="http://schemas.microsoft.com/office/powerpoint/2010/main" val="3500934212"/>
+        <p14:creationId xmlns:p14="http://schemas.microsoft.com/office/powerpoint/2010/main" val="3842629019"/>
       </p:ext>
     </p:extLst>
   </p:cSld>
@@ -4856,7 +4856,7 @@
           <p:cNvPr id="2" name="TextBox 1">
             <a:extLst>
               <a:ext uri="{FF2B5EF4-FFF2-40B4-BE49-F238E27FC236}">
-                <a16:creationId xmlns:a16="http://schemas.microsoft.com/office/drawing/2014/main" id="{4FEAA4DE-1883-E343-9EE2-E42150DD4B8C}"/>
+                <a16:creationId xmlns:a16="http://schemas.microsoft.com/office/drawing/2014/main" id="{36E11B58-9FE8-05FD-9FE4-F72BA6360DC9}"/>
               </a:ext>
             </a:extLst>
           </p:cNvPr>
@@ -4901,7 +4901,7 @@
           <p:cNvPr id="3" name="TextBox 2">
             <a:extLst>
               <a:ext uri="{FF2B5EF4-FFF2-40B4-BE49-F238E27FC236}">
-                <a16:creationId xmlns:a16="http://schemas.microsoft.com/office/drawing/2014/main" id="{AD221F3E-3D2C-286A-10BD-D19850F1D327}"/>
+                <a16:creationId xmlns:a16="http://schemas.microsoft.com/office/drawing/2014/main" id="{64CF4E24-DBCC-2461-7CDC-BA2379C1CD56}"/>
               </a:ext>
             </a:extLst>
           </p:cNvPr>
@@ -4952,7 +4952,7 @@
           <p:cNvPr id="4" name="TextBox 3">
             <a:extLst>
               <a:ext uri="{FF2B5EF4-FFF2-40B4-BE49-F238E27FC236}">
-                <a16:creationId xmlns:a16="http://schemas.microsoft.com/office/drawing/2014/main" id="{D41C1758-14F0-00AE-A43A-787C9403B57B}"/>
+                <a16:creationId xmlns:a16="http://schemas.microsoft.com/office/drawing/2014/main" id="{7697B923-2CB0-94F1-A180-C80C8E5A50D5}"/>
               </a:ext>
             </a:extLst>
           </p:cNvPr>
@@ -5017,7 +5017,7 @@
     </p:spTree>
     <p:extLst>
       <p:ext uri="{BB962C8B-B14F-4D97-AF65-F5344CB8AC3E}">
-        <p14:creationId xmlns:p14="http://schemas.microsoft.com/office/powerpoint/2010/main" val="3014271227"/>
+        <p14:creationId xmlns:p14="http://schemas.microsoft.com/office/powerpoint/2010/main" val="3700762624"/>
       </p:ext>
     </p:extLst>
   </p:cSld>
@@ -5049,7 +5049,7 @@
           <p:cNvPr id="2" name="TextBox 1">
             <a:extLst>
               <a:ext uri="{FF2B5EF4-FFF2-40B4-BE49-F238E27FC236}">
-                <a16:creationId xmlns:a16="http://schemas.microsoft.com/office/drawing/2014/main" id="{2064D05E-0581-982E-400F-3551BF5F9B88}"/>
+                <a16:creationId xmlns:a16="http://schemas.microsoft.com/office/drawing/2014/main" id="{782854FF-432E-B365-3554-371C50AF57BF}"/>
               </a:ext>
             </a:extLst>
           </p:cNvPr>
@@ -5095,7 +5095,7 @@
           <p:cNvPr id="3" name="Straight Connector 2">
             <a:extLst>
               <a:ext uri="{FF2B5EF4-FFF2-40B4-BE49-F238E27FC236}">
-                <a16:creationId xmlns:a16="http://schemas.microsoft.com/office/drawing/2014/main" id="{FA58E70A-2F4D-424F-D499-143DD8243E8E}"/>
+                <a16:creationId xmlns:a16="http://schemas.microsoft.com/office/drawing/2014/main" id="{9008794F-F5BB-DB14-6884-6D25F05AF255}"/>
               </a:ext>
             </a:extLst>
           </p:cNvPr>
@@ -5136,7 +5136,7 @@
           <p:cNvPr id="5" name="Picture 4">
             <a:extLst>
               <a:ext uri="{FF2B5EF4-FFF2-40B4-BE49-F238E27FC236}">
-                <a16:creationId xmlns:a16="http://schemas.microsoft.com/office/drawing/2014/main" id="{406A3FB4-0995-04E7-FFB5-A72BA7C9C5EE}"/>
+                <a16:creationId xmlns:a16="http://schemas.microsoft.com/office/drawing/2014/main" id="{B3093DE6-D74F-3A53-C9D3-D29E92F7FCBF}"/>
               </a:ext>
             </a:extLst>
           </p:cNvPr>
@@ -5172,7 +5172,7 @@
           <p:cNvPr id="6" name="TextBox 5">
             <a:extLst>
               <a:ext uri="{FF2B5EF4-FFF2-40B4-BE49-F238E27FC236}">
-                <a16:creationId xmlns:a16="http://schemas.microsoft.com/office/drawing/2014/main" id="{96544256-291E-98E4-5949-FA2F07A9EA97}"/>
+                <a16:creationId xmlns:a16="http://schemas.microsoft.com/office/drawing/2014/main" id="{4C329C6B-D15A-C784-E4BD-889A33450453}"/>
               </a:ext>
             </a:extLst>
           </p:cNvPr>
@@ -5217,7 +5217,7 @@
           <p:cNvPr id="7" name="TextBox 6">
             <a:extLst>
               <a:ext uri="{FF2B5EF4-FFF2-40B4-BE49-F238E27FC236}">
-                <a16:creationId xmlns:a16="http://schemas.microsoft.com/office/drawing/2014/main" id="{015A8F78-6DA9-1017-F0F2-92E3C79FD600}"/>
+                <a16:creationId xmlns:a16="http://schemas.microsoft.com/office/drawing/2014/main" id="{0AD636E8-A56B-4963-7EC9-6135F742802C}"/>
               </a:ext>
             </a:extLst>
           </p:cNvPr>
@@ -5268,7 +5268,7 @@
           <p:cNvPr id="8" name="TextBox 7">
             <a:extLst>
               <a:ext uri="{FF2B5EF4-FFF2-40B4-BE49-F238E27FC236}">
-                <a16:creationId xmlns:a16="http://schemas.microsoft.com/office/drawing/2014/main" id="{A842D3ED-D3FC-0815-4183-A6B2B1C68401}"/>
+                <a16:creationId xmlns:a16="http://schemas.microsoft.com/office/drawing/2014/main" id="{8A9E94E1-5519-3C8F-36C4-EC8368D26F70}"/>
               </a:ext>
             </a:extLst>
           </p:cNvPr>
@@ -5351,7 +5351,7 @@
           <p:cNvPr id="9" name="TextBox 8">
             <a:extLst>
               <a:ext uri="{FF2B5EF4-FFF2-40B4-BE49-F238E27FC236}">
-                <a16:creationId xmlns:a16="http://schemas.microsoft.com/office/drawing/2014/main" id="{027C55C3-F8EA-61FA-9F66-ED9B82BDFCB9}"/>
+                <a16:creationId xmlns:a16="http://schemas.microsoft.com/office/drawing/2014/main" id="{D3FA2E5E-F1E9-8E48-1FAC-C55C01E9A4EA}"/>
               </a:ext>
             </a:extLst>
           </p:cNvPr>
@@ -5390,7 +5390,7 @@
     </p:spTree>
     <p:extLst>
       <p:ext uri="{BB962C8B-B14F-4D97-AF65-F5344CB8AC3E}">
-        <p14:creationId xmlns:p14="http://schemas.microsoft.com/office/powerpoint/2010/main" val="2057756239"/>
+        <p14:creationId xmlns:p14="http://schemas.microsoft.com/office/powerpoint/2010/main" val="2082553552"/>
       </p:ext>
     </p:extLst>
   </p:cSld>
@@ -5422,7 +5422,7 @@
           <p:cNvPr id="2" name="TextBox 1">
             <a:extLst>
               <a:ext uri="{FF2B5EF4-FFF2-40B4-BE49-F238E27FC236}">
-                <a16:creationId xmlns:a16="http://schemas.microsoft.com/office/drawing/2014/main" id="{483342A2-3C2D-51E6-C7A1-C9648B26A43B}"/>
+                <a16:creationId xmlns:a16="http://schemas.microsoft.com/office/drawing/2014/main" id="{5D95C54F-DA45-B7C3-CDD0-1A338C8D19D3}"/>
               </a:ext>
             </a:extLst>
           </p:cNvPr>
@@ -5468,7 +5468,7 @@
           <p:cNvPr id="3" name="Straight Connector 2">
             <a:extLst>
               <a:ext uri="{FF2B5EF4-FFF2-40B4-BE49-F238E27FC236}">
-                <a16:creationId xmlns:a16="http://schemas.microsoft.com/office/drawing/2014/main" id="{E4465AC7-916E-2795-DFC1-14220866D751}"/>
+                <a16:creationId xmlns:a16="http://schemas.microsoft.com/office/drawing/2014/main" id="{9B3E1915-1E9B-93CF-CB0C-0C146613A26B}"/>
               </a:ext>
             </a:extLst>
           </p:cNvPr>
@@ -5509,7 +5509,7 @@
           <p:cNvPr id="4" name="TextBox 3">
             <a:extLst>
               <a:ext uri="{FF2B5EF4-FFF2-40B4-BE49-F238E27FC236}">
-                <a16:creationId xmlns:a16="http://schemas.microsoft.com/office/drawing/2014/main" id="{3D373425-079F-8351-702B-664B81801074}"/>
+                <a16:creationId xmlns:a16="http://schemas.microsoft.com/office/drawing/2014/main" id="{C65351E5-52E1-B2F0-7D70-3A3339DBBD26}"/>
               </a:ext>
             </a:extLst>
           </p:cNvPr>
@@ -5664,7 +5664,7 @@
           <p:cNvPr id="5" name="Rectangle: Rounded Corners 4">
             <a:extLst>
               <a:ext uri="{FF2B5EF4-FFF2-40B4-BE49-F238E27FC236}">
-                <a16:creationId xmlns:a16="http://schemas.microsoft.com/office/drawing/2014/main" id="{B850A6FC-A30F-BF7F-F89D-FBC0BDB2FB74}"/>
+                <a16:creationId xmlns:a16="http://schemas.microsoft.com/office/drawing/2014/main" id="{7FAA95E1-002A-B66D-84E6-6AD069D6844A}"/>
               </a:ext>
             </a:extLst>
           </p:cNvPr>
@@ -5748,7 +5748,7 @@
           <p:cNvPr id="6" name="TextBox 5">
             <a:extLst>
               <a:ext uri="{FF2B5EF4-FFF2-40B4-BE49-F238E27FC236}">
-                <a16:creationId xmlns:a16="http://schemas.microsoft.com/office/drawing/2014/main" id="{5F47228F-C7A7-817F-6F6A-83FFF0340196}"/>
+                <a16:creationId xmlns:a16="http://schemas.microsoft.com/office/drawing/2014/main" id="{EA8CC43C-3EB6-E882-EDAC-0F3C4788C30F}"/>
               </a:ext>
             </a:extLst>
           </p:cNvPr>
@@ -5787,7 +5787,7 @@
     </p:spTree>
     <p:extLst>
       <p:ext uri="{BB962C8B-B14F-4D97-AF65-F5344CB8AC3E}">
-        <p14:creationId xmlns:p14="http://schemas.microsoft.com/office/powerpoint/2010/main" val="1236772252"/>
+        <p14:creationId xmlns:p14="http://schemas.microsoft.com/office/powerpoint/2010/main" val="2632823513"/>
       </p:ext>
     </p:extLst>
   </p:cSld>
@@ -5819,7 +5819,7 @@
           <p:cNvPr id="2" name="TextBox 1">
             <a:extLst>
               <a:ext uri="{FF2B5EF4-FFF2-40B4-BE49-F238E27FC236}">
-                <a16:creationId xmlns:a16="http://schemas.microsoft.com/office/drawing/2014/main" id="{D6D5FFC6-2244-556C-0897-CA50704899B5}"/>
+                <a16:creationId xmlns:a16="http://schemas.microsoft.com/office/drawing/2014/main" id="{E7009848-8C70-A82A-7727-8BCBA8E1BC1A}"/>
               </a:ext>
             </a:extLst>
           </p:cNvPr>
@@ -5865,7 +5865,7 @@
           <p:cNvPr id="3" name="Straight Connector 2">
             <a:extLst>
               <a:ext uri="{FF2B5EF4-FFF2-40B4-BE49-F238E27FC236}">
-                <a16:creationId xmlns:a16="http://schemas.microsoft.com/office/drawing/2014/main" id="{37258F0A-3D04-7A90-AC9A-D7DECA0402D6}"/>
+                <a16:creationId xmlns:a16="http://schemas.microsoft.com/office/drawing/2014/main" id="{4892B33D-2D7E-B9A0-9F44-B93AFCDF0794}"/>
               </a:ext>
             </a:extLst>
           </p:cNvPr>
@@ -5906,7 +5906,7 @@
           <p:cNvPr id="4" name="TextBox 3">
             <a:extLst>
               <a:ext uri="{FF2B5EF4-FFF2-40B4-BE49-F238E27FC236}">
-                <a16:creationId xmlns:a16="http://schemas.microsoft.com/office/drawing/2014/main" id="{42542D81-B414-0CEE-DF01-B7D37388104A}"/>
+                <a16:creationId xmlns:a16="http://schemas.microsoft.com/office/drawing/2014/main" id="{8A9037D1-448C-911D-1424-5B1302E890E7}"/>
               </a:ext>
             </a:extLst>
           </p:cNvPr>
@@ -6036,7 +6036,7 @@
                 </a:solidFill>
                 <a:latin typeface="Calibri" panose="020F0502020204030204" pitchFamily="34" charset="0"/>
               </a:rPr>
-              <a:t>Five verification passes:</a:t>
+              <a:t>Six verification passes:</a:t>
             </a:r>
             <a:r>
               <a:rPr lang="en-US" sz="1900">
@@ -6091,7 +6091,7 @@
           <p:cNvPr id="5" name="TextBox 4">
             <a:extLst>
               <a:ext uri="{FF2B5EF4-FFF2-40B4-BE49-F238E27FC236}">
-                <a16:creationId xmlns:a16="http://schemas.microsoft.com/office/drawing/2014/main" id="{294B681A-970A-03EA-50D8-4759C88A6FB6}"/>
+                <a16:creationId xmlns:a16="http://schemas.microsoft.com/office/drawing/2014/main" id="{EDC8DB9C-9F1F-2844-7223-A9EE31D6945C}"/>
               </a:ext>
             </a:extLst>
           </p:cNvPr>
@@ -6130,7 +6130,7 @@
     </p:spTree>
     <p:extLst>
       <p:ext uri="{BB962C8B-B14F-4D97-AF65-F5344CB8AC3E}">
-        <p14:creationId xmlns:p14="http://schemas.microsoft.com/office/powerpoint/2010/main" val="142055569"/>
+        <p14:creationId xmlns:p14="http://schemas.microsoft.com/office/powerpoint/2010/main" val="2355521339"/>
       </p:ext>
     </p:extLst>
   </p:cSld>
@@ -6162,7 +6162,7 @@
           <p:cNvPr id="2" name="TextBox 1">
             <a:extLst>
               <a:ext uri="{FF2B5EF4-FFF2-40B4-BE49-F238E27FC236}">
-                <a16:creationId xmlns:a16="http://schemas.microsoft.com/office/drawing/2014/main" id="{9FE8F167-C630-2149-C961-33331C3790B5}"/>
+                <a16:creationId xmlns:a16="http://schemas.microsoft.com/office/drawing/2014/main" id="{A897FD8E-1014-8405-D071-DBFDF56468F8}"/>
               </a:ext>
             </a:extLst>
           </p:cNvPr>
@@ -6202,7 +6202,7 @@
           <p:cNvPr id="3" name="Straight Connector 2">
             <a:extLst>
               <a:ext uri="{FF2B5EF4-FFF2-40B4-BE49-F238E27FC236}">
-                <a16:creationId xmlns:a16="http://schemas.microsoft.com/office/drawing/2014/main" id="{DFAF732F-9884-05DC-937B-D8D4DF147170}"/>
+                <a16:creationId xmlns:a16="http://schemas.microsoft.com/office/drawing/2014/main" id="{B7506961-08DC-DA84-A056-9EDA8D1078A4}"/>
               </a:ext>
             </a:extLst>
           </p:cNvPr>
@@ -6243,7 +6243,7 @@
           <p:cNvPr id="4" name="TextBox 3">
             <a:extLst>
               <a:ext uri="{FF2B5EF4-FFF2-40B4-BE49-F238E27FC236}">
-                <a16:creationId xmlns:a16="http://schemas.microsoft.com/office/drawing/2014/main" id="{B294DE1A-3701-B63D-69DD-FA8D63D5E0C6}"/>
+                <a16:creationId xmlns:a16="http://schemas.microsoft.com/office/drawing/2014/main" id="{4A80F894-F039-BCD9-E182-F9395EAB0F97}"/>
               </a:ext>
             </a:extLst>
           </p:cNvPr>
@@ -6288,7 +6288,7 @@
           <p:cNvPr id="5" name="TextBox 4">
             <a:extLst>
               <a:ext uri="{FF2B5EF4-FFF2-40B4-BE49-F238E27FC236}">
-                <a16:creationId xmlns:a16="http://schemas.microsoft.com/office/drawing/2014/main" id="{4C42EC81-0AA0-7078-6CF1-6EE0086189F6}"/>
+                <a16:creationId xmlns:a16="http://schemas.microsoft.com/office/drawing/2014/main" id="{74726DD3-2379-DB57-139B-8408F01F76D7}"/>
               </a:ext>
             </a:extLst>
           </p:cNvPr>
@@ -6443,7 +6443,7 @@
           <p:cNvPr id="6" name="TextBox 5">
             <a:extLst>
               <a:ext uri="{FF2B5EF4-FFF2-40B4-BE49-F238E27FC236}">
-                <a16:creationId xmlns:a16="http://schemas.microsoft.com/office/drawing/2014/main" id="{137F8AAB-39B7-F894-2960-A95928719ED2}"/>
+                <a16:creationId xmlns:a16="http://schemas.microsoft.com/office/drawing/2014/main" id="{599F7CD1-F50C-1FD4-A190-6EE4BA02272F}"/>
               </a:ext>
             </a:extLst>
           </p:cNvPr>
@@ -6488,7 +6488,7 @@
           <p:cNvPr id="7" name="TextBox 6">
             <a:extLst>
               <a:ext uri="{FF2B5EF4-FFF2-40B4-BE49-F238E27FC236}">
-                <a16:creationId xmlns:a16="http://schemas.microsoft.com/office/drawing/2014/main" id="{91342C0F-62A7-9957-75B4-397842602DEF}"/>
+                <a16:creationId xmlns:a16="http://schemas.microsoft.com/office/drawing/2014/main" id="{05930B6F-ACAC-9CAE-D213-F94A6476EA19}"/>
               </a:ext>
             </a:extLst>
           </p:cNvPr>
@@ -6628,7 +6628,7 @@
           <p:cNvPr id="8" name="TextBox 7">
             <a:extLst>
               <a:ext uri="{FF2B5EF4-FFF2-40B4-BE49-F238E27FC236}">
-                <a16:creationId xmlns:a16="http://schemas.microsoft.com/office/drawing/2014/main" id="{1B2391A2-CE55-F082-9780-C4D2A0B38C15}"/>
+                <a16:creationId xmlns:a16="http://schemas.microsoft.com/office/drawing/2014/main" id="{6DAFC058-8D4D-05A4-C176-369413CCA2EF}"/>
               </a:ext>
             </a:extLst>
           </p:cNvPr>
@@ -6667,7 +6667,7 @@
     </p:spTree>
     <p:extLst>
       <p:ext uri="{BB962C8B-B14F-4D97-AF65-F5344CB8AC3E}">
-        <p14:creationId xmlns:p14="http://schemas.microsoft.com/office/powerpoint/2010/main" val="2995287813"/>
+        <p14:creationId xmlns:p14="http://schemas.microsoft.com/office/powerpoint/2010/main" val="683369087"/>
       </p:ext>
     </p:extLst>
   </p:cSld>
@@ -6699,7 +6699,7 @@
           <p:cNvPr id="2" name="TextBox 1">
             <a:extLst>
               <a:ext uri="{FF2B5EF4-FFF2-40B4-BE49-F238E27FC236}">
-                <a16:creationId xmlns:a16="http://schemas.microsoft.com/office/drawing/2014/main" id="{AA3423FC-AA1B-77EB-742A-3B8AF06A4D6D}"/>
+                <a16:creationId xmlns:a16="http://schemas.microsoft.com/office/drawing/2014/main" id="{E5D7DEC6-EFA7-1221-3D2C-F8CADB655F3A}"/>
               </a:ext>
             </a:extLst>
           </p:cNvPr>
@@ -6745,7 +6745,7 @@
           <p:cNvPr id="3" name="Straight Connector 2">
             <a:extLst>
               <a:ext uri="{FF2B5EF4-FFF2-40B4-BE49-F238E27FC236}">
-                <a16:creationId xmlns:a16="http://schemas.microsoft.com/office/drawing/2014/main" id="{4CB613EB-59BC-A9CF-980C-E2E2C44E32CD}"/>
+                <a16:creationId xmlns:a16="http://schemas.microsoft.com/office/drawing/2014/main" id="{1033BC60-0639-E188-82CD-B753A423D7FF}"/>
               </a:ext>
             </a:extLst>
           </p:cNvPr>
@@ -6786,7 +6786,7 @@
           <p:cNvPr id="4" name="TextBox 3">
             <a:extLst>
               <a:ext uri="{FF2B5EF4-FFF2-40B4-BE49-F238E27FC236}">
-                <a16:creationId xmlns:a16="http://schemas.microsoft.com/office/drawing/2014/main" id="{862892B0-5B11-5CE7-49D6-EF746C68F5EC}"/>
+                <a16:creationId xmlns:a16="http://schemas.microsoft.com/office/drawing/2014/main" id="{FDEB5F32-50A4-4B89-CE98-DCDB71012634}"/>
               </a:ext>
             </a:extLst>
           </p:cNvPr>
@@ -6911,7 +6911,7 @@
           <p:cNvPr id="5" name="Rectangle: Rounded Corners 4">
             <a:extLst>
               <a:ext uri="{FF2B5EF4-FFF2-40B4-BE49-F238E27FC236}">
-                <a16:creationId xmlns:a16="http://schemas.microsoft.com/office/drawing/2014/main" id="{3B07901D-29EC-D30E-FCE2-90C54D8C4557}"/>
+                <a16:creationId xmlns:a16="http://schemas.microsoft.com/office/drawing/2014/main" id="{B85F0129-4DF6-CFCE-2D11-313DC72577E1}"/>
               </a:ext>
             </a:extLst>
           </p:cNvPr>
@@ -6989,7 +6989,7 @@
           <p:cNvPr id="6" name="TextBox 5">
             <a:extLst>
               <a:ext uri="{FF2B5EF4-FFF2-40B4-BE49-F238E27FC236}">
-                <a16:creationId xmlns:a16="http://schemas.microsoft.com/office/drawing/2014/main" id="{D8C83BDD-73FD-8FC6-F292-2065F1B6B884}"/>
+                <a16:creationId xmlns:a16="http://schemas.microsoft.com/office/drawing/2014/main" id="{C45C852B-0287-DF47-DE2B-E652CAD92F28}"/>
               </a:ext>
             </a:extLst>
           </p:cNvPr>
@@ -7040,7 +7040,7 @@
           <p:cNvPr id="7" name="Rectangle: Rounded Corners 6">
             <a:extLst>
               <a:ext uri="{FF2B5EF4-FFF2-40B4-BE49-F238E27FC236}">
-                <a16:creationId xmlns:a16="http://schemas.microsoft.com/office/drawing/2014/main" id="{F9A5386A-2F61-5C4B-11CD-C0FDD6A32F8C}"/>
+                <a16:creationId xmlns:a16="http://schemas.microsoft.com/office/drawing/2014/main" id="{689A940D-1DC0-107A-AF01-17CC6D3FE835}"/>
               </a:ext>
             </a:extLst>
           </p:cNvPr>
@@ -7124,7 +7124,7 @@
           <p:cNvPr id="8" name="TextBox 7">
             <a:extLst>
               <a:ext uri="{FF2B5EF4-FFF2-40B4-BE49-F238E27FC236}">
-                <a16:creationId xmlns:a16="http://schemas.microsoft.com/office/drawing/2014/main" id="{D0E29235-EB82-811D-10E6-F9A5F697819C}"/>
+                <a16:creationId xmlns:a16="http://schemas.microsoft.com/office/drawing/2014/main" id="{E2E0D20A-8E5E-360A-7457-A7207E09A2FD}"/>
               </a:ext>
             </a:extLst>
           </p:cNvPr>
@@ -7163,7 +7163,7 @@
     </p:spTree>
     <p:extLst>
       <p:ext uri="{BB962C8B-B14F-4D97-AF65-F5344CB8AC3E}">
-        <p14:creationId xmlns:p14="http://schemas.microsoft.com/office/powerpoint/2010/main" val="601922660"/>
+        <p14:creationId xmlns:p14="http://schemas.microsoft.com/office/powerpoint/2010/main" val="1584865836"/>
       </p:ext>
     </p:extLst>
   </p:cSld>
@@ -7195,7 +7195,7 @@
           <p:cNvPr id="2" name="TextBox 1">
             <a:extLst>
               <a:ext uri="{FF2B5EF4-FFF2-40B4-BE49-F238E27FC236}">
-                <a16:creationId xmlns:a16="http://schemas.microsoft.com/office/drawing/2014/main" id="{3C4C636C-30F9-2B36-045F-F6701429EFD4}"/>
+                <a16:creationId xmlns:a16="http://schemas.microsoft.com/office/drawing/2014/main" id="{B16A4CEA-02DE-AF40-E47D-2B01DADF99A4}"/>
               </a:ext>
             </a:extLst>
           </p:cNvPr>
@@ -7241,7 +7241,7 @@
           <p:cNvPr id="3" name="Straight Connector 2">
             <a:extLst>
               <a:ext uri="{FF2B5EF4-FFF2-40B4-BE49-F238E27FC236}">
-                <a16:creationId xmlns:a16="http://schemas.microsoft.com/office/drawing/2014/main" id="{B40D706F-8949-0FC2-2C02-0DFDB17C1F92}"/>
+                <a16:creationId xmlns:a16="http://schemas.microsoft.com/office/drawing/2014/main" id="{39DE2A2D-3D14-AC73-9DD0-6718F42AB76C}"/>
               </a:ext>
             </a:extLst>
           </p:cNvPr>
@@ -7282,7 +7282,7 @@
           <p:cNvPr id="4" name="Rectangle: Rounded Corners 3">
             <a:extLst>
               <a:ext uri="{FF2B5EF4-FFF2-40B4-BE49-F238E27FC236}">
-                <a16:creationId xmlns:a16="http://schemas.microsoft.com/office/drawing/2014/main" id="{2B8A57FB-B182-3A6D-DA95-063BE7A904D6}"/>
+                <a16:creationId xmlns:a16="http://schemas.microsoft.com/office/drawing/2014/main" id="{ACF2F23C-F06F-AE93-F869-AF0101F921FE}"/>
               </a:ext>
             </a:extLst>
           </p:cNvPr>
@@ -7361,7 +7361,7 @@
           <p:cNvPr id="5" name="TextBox 4">
             <a:extLst>
               <a:ext uri="{FF2B5EF4-FFF2-40B4-BE49-F238E27FC236}">
-                <a16:creationId xmlns:a16="http://schemas.microsoft.com/office/drawing/2014/main" id="{FDB17B4D-88D5-A9F1-F54E-CF26AF72AAA7}"/>
+                <a16:creationId xmlns:a16="http://schemas.microsoft.com/office/drawing/2014/main" id="{95BC93C7-2DE0-5D06-43E9-3638BC28BEBE}"/>
               </a:ext>
             </a:extLst>
           </p:cNvPr>
@@ -7412,7 +7412,7 @@
           <p:cNvPr id="6" name="Rectangle: Rounded Corners 5">
             <a:extLst>
               <a:ext uri="{FF2B5EF4-FFF2-40B4-BE49-F238E27FC236}">
-                <a16:creationId xmlns:a16="http://schemas.microsoft.com/office/drawing/2014/main" id="{35ECEC3D-AFF3-152E-6B71-028742E017D0}"/>
+                <a16:creationId xmlns:a16="http://schemas.microsoft.com/office/drawing/2014/main" id="{545784B7-1537-BC5C-2795-DB1B59B7FFAA}"/>
               </a:ext>
             </a:extLst>
           </p:cNvPr>
@@ -7491,7 +7491,7 @@
           <p:cNvPr id="7" name="TextBox 6">
             <a:extLst>
               <a:ext uri="{FF2B5EF4-FFF2-40B4-BE49-F238E27FC236}">
-                <a16:creationId xmlns:a16="http://schemas.microsoft.com/office/drawing/2014/main" id="{9FF48521-65CC-3C42-E6CB-98BC919F2286}"/>
+                <a16:creationId xmlns:a16="http://schemas.microsoft.com/office/drawing/2014/main" id="{A0A6C9C5-DE32-1BC7-773E-53AB9D7B994D}"/>
               </a:ext>
             </a:extLst>
           </p:cNvPr>
@@ -7542,7 +7542,7 @@
           <p:cNvPr id="8" name="Arrow: Right 7">
             <a:extLst>
               <a:ext uri="{FF2B5EF4-FFF2-40B4-BE49-F238E27FC236}">
-                <a16:creationId xmlns:a16="http://schemas.microsoft.com/office/drawing/2014/main" id="{38B3A701-589B-C9F6-A86C-E244BBC05273}"/>
+                <a16:creationId xmlns:a16="http://schemas.microsoft.com/office/drawing/2014/main" id="{FBF8B972-570F-353E-DAB5-339CEA0E073F}"/>
               </a:ext>
             </a:extLst>
           </p:cNvPr>
@@ -7615,7 +7615,7 @@
           <p:cNvPr id="9" name="Rectangle: Rounded Corners 8">
             <a:extLst>
               <a:ext uri="{FF2B5EF4-FFF2-40B4-BE49-F238E27FC236}">
-                <a16:creationId xmlns:a16="http://schemas.microsoft.com/office/drawing/2014/main" id="{6067E58C-C4E3-25FB-0C46-B5B76947A576}"/>
+                <a16:creationId xmlns:a16="http://schemas.microsoft.com/office/drawing/2014/main" id="{71E7702D-A69A-DE53-2E50-32CCE50D0BB1}"/>
               </a:ext>
             </a:extLst>
           </p:cNvPr>
@@ -7694,7 +7694,7 @@
           <p:cNvPr id="10" name="TextBox 9">
             <a:extLst>
               <a:ext uri="{FF2B5EF4-FFF2-40B4-BE49-F238E27FC236}">
-                <a16:creationId xmlns:a16="http://schemas.microsoft.com/office/drawing/2014/main" id="{44CD028D-0978-0D1D-1A01-F34289156717}"/>
+                <a16:creationId xmlns:a16="http://schemas.microsoft.com/office/drawing/2014/main" id="{92C3CC8C-BF9A-DDB0-392E-84E51DF4B5B9}"/>
               </a:ext>
             </a:extLst>
           </p:cNvPr>
@@ -7745,7 +7745,7 @@
           <p:cNvPr id="11" name="TextBox 10">
             <a:extLst>
               <a:ext uri="{FF2B5EF4-FFF2-40B4-BE49-F238E27FC236}">
-                <a16:creationId xmlns:a16="http://schemas.microsoft.com/office/drawing/2014/main" id="{D55EDD6A-AC1A-E9BF-C526-0CE2BE6F5776}"/>
+                <a16:creationId xmlns:a16="http://schemas.microsoft.com/office/drawing/2014/main" id="{55F74B52-F39E-AAAC-F395-260F58435A53}"/>
               </a:ext>
             </a:extLst>
           </p:cNvPr>
@@ -7796,7 +7796,7 @@
           <p:cNvPr id="12" name="TextBox 11">
             <a:extLst>
               <a:ext uri="{FF2B5EF4-FFF2-40B4-BE49-F238E27FC236}">
-                <a16:creationId xmlns:a16="http://schemas.microsoft.com/office/drawing/2014/main" id="{89F2FC61-5580-4B3D-0E30-DF286269F049}"/>
+                <a16:creationId xmlns:a16="http://schemas.microsoft.com/office/drawing/2014/main" id="{11949780-DD21-59AF-5C60-E4F698921311}"/>
               </a:ext>
             </a:extLst>
           </p:cNvPr>
@@ -7835,7 +7835,7 @@
     </p:spTree>
     <p:extLst>
       <p:ext uri="{BB962C8B-B14F-4D97-AF65-F5344CB8AC3E}">
-        <p14:creationId xmlns:p14="http://schemas.microsoft.com/office/powerpoint/2010/main" val="2533677266"/>
+        <p14:creationId xmlns:p14="http://schemas.microsoft.com/office/powerpoint/2010/main" val="2702197453"/>
       </p:ext>
     </p:extLst>
   </p:cSld>
@@ -7867,7 +7867,7 @@
           <p:cNvPr id="2" name="TextBox 1">
             <a:extLst>
               <a:ext uri="{FF2B5EF4-FFF2-40B4-BE49-F238E27FC236}">
-                <a16:creationId xmlns:a16="http://schemas.microsoft.com/office/drawing/2014/main" id="{2D3C72EB-9788-9D86-9D3B-3A94585A941D}"/>
+                <a16:creationId xmlns:a16="http://schemas.microsoft.com/office/drawing/2014/main" id="{86163896-A2B5-392B-AADB-94D1C93F5E46}"/>
               </a:ext>
             </a:extLst>
           </p:cNvPr>
@@ -7913,7 +7913,7 @@
           <p:cNvPr id="3" name="Straight Connector 2">
             <a:extLst>
               <a:ext uri="{FF2B5EF4-FFF2-40B4-BE49-F238E27FC236}">
-                <a16:creationId xmlns:a16="http://schemas.microsoft.com/office/drawing/2014/main" id="{2D95617D-5377-2E87-6DB0-1AA497AB3274}"/>
+                <a16:creationId xmlns:a16="http://schemas.microsoft.com/office/drawing/2014/main" id="{93BB874E-B2C1-CD27-A96B-B7F3A388542E}"/>
               </a:ext>
             </a:extLst>
           </p:cNvPr>
@@ -7954,7 +7954,7 @@
           <p:cNvPr id="4" name="TextBox 3">
             <a:extLst>
               <a:ext uri="{FF2B5EF4-FFF2-40B4-BE49-F238E27FC236}">
-                <a16:creationId xmlns:a16="http://schemas.microsoft.com/office/drawing/2014/main" id="{1D28FB58-6E05-2004-BF24-403CCB1FD518}"/>
+                <a16:creationId xmlns:a16="http://schemas.microsoft.com/office/drawing/2014/main" id="{BC095B82-6271-EE77-5DD9-C69DD9ECD4A6}"/>
               </a:ext>
             </a:extLst>
           </p:cNvPr>
@@ -7999,7 +7999,7 @@
           <p:cNvPr id="5" name="TextBox 4">
             <a:extLst>
               <a:ext uri="{FF2B5EF4-FFF2-40B4-BE49-F238E27FC236}">
-                <a16:creationId xmlns:a16="http://schemas.microsoft.com/office/drawing/2014/main" id="{495AFF6E-ACBC-08EA-D3B7-968E3A42F43F}"/>
+                <a16:creationId xmlns:a16="http://schemas.microsoft.com/office/drawing/2014/main" id="{4310CE9E-C239-3D36-59A4-EB696BA148F7}"/>
               </a:ext>
             </a:extLst>
           </p:cNvPr>
@@ -8066,7 +8066,7 @@
           <p:cNvPr id="6" name="TextBox 5">
             <a:extLst>
               <a:ext uri="{FF2B5EF4-FFF2-40B4-BE49-F238E27FC236}">
-                <a16:creationId xmlns:a16="http://schemas.microsoft.com/office/drawing/2014/main" id="{1ACD7B97-374B-FE27-5D56-D4B69DBA12EF}"/>
+                <a16:creationId xmlns:a16="http://schemas.microsoft.com/office/drawing/2014/main" id="{8B4C9159-1CDC-B560-F97E-628BCEAD413F}"/>
               </a:ext>
             </a:extLst>
           </p:cNvPr>
@@ -8111,7 +8111,7 @@
           <p:cNvPr id="7" name="TextBox 6">
             <a:extLst>
               <a:ext uri="{FF2B5EF4-FFF2-40B4-BE49-F238E27FC236}">
-                <a16:creationId xmlns:a16="http://schemas.microsoft.com/office/drawing/2014/main" id="{F55F037A-8658-1544-EDD4-ED6E7A0C375B}"/>
+                <a16:creationId xmlns:a16="http://schemas.microsoft.com/office/drawing/2014/main" id="{EA3C3187-A3B3-C9F9-D122-2D2B5D443042}"/>
               </a:ext>
             </a:extLst>
           </p:cNvPr>
@@ -8178,7 +8178,7 @@
           <p:cNvPr id="8" name="TextBox 7">
             <a:extLst>
               <a:ext uri="{FF2B5EF4-FFF2-40B4-BE49-F238E27FC236}">
-                <a16:creationId xmlns:a16="http://schemas.microsoft.com/office/drawing/2014/main" id="{2BDD30FC-FA8D-4944-1D5A-3DB3AA469A37}"/>
+                <a16:creationId xmlns:a16="http://schemas.microsoft.com/office/drawing/2014/main" id="{608F0101-A343-F4F2-38C2-8073C1229949}"/>
               </a:ext>
             </a:extLst>
           </p:cNvPr>
@@ -8223,7 +8223,7 @@
           <p:cNvPr id="9" name="TextBox 8">
             <a:extLst>
               <a:ext uri="{FF2B5EF4-FFF2-40B4-BE49-F238E27FC236}">
-                <a16:creationId xmlns:a16="http://schemas.microsoft.com/office/drawing/2014/main" id="{D7DBCB05-ABEB-1567-A208-2540C15C6E2E}"/>
+                <a16:creationId xmlns:a16="http://schemas.microsoft.com/office/drawing/2014/main" id="{EAA8F984-1330-4736-E435-96DD5159F0C6}"/>
               </a:ext>
             </a:extLst>
           </p:cNvPr>
@@ -8290,7 +8290,7 @@
           <p:cNvPr id="10" name="TextBox 9">
             <a:extLst>
               <a:ext uri="{FF2B5EF4-FFF2-40B4-BE49-F238E27FC236}">
-                <a16:creationId xmlns:a16="http://schemas.microsoft.com/office/drawing/2014/main" id="{3B4EDDCD-2253-78DD-FC17-78AB1C80FC9F}"/>
+                <a16:creationId xmlns:a16="http://schemas.microsoft.com/office/drawing/2014/main" id="{8BA751FB-411F-5309-E19A-917C9C124720}"/>
               </a:ext>
             </a:extLst>
           </p:cNvPr>
@@ -8335,7 +8335,7 @@
           <p:cNvPr id="11" name="TextBox 10">
             <a:extLst>
               <a:ext uri="{FF2B5EF4-FFF2-40B4-BE49-F238E27FC236}">
-                <a16:creationId xmlns:a16="http://schemas.microsoft.com/office/drawing/2014/main" id="{5FE4D8E0-3697-3611-F3C6-A9C99FAAA1D6}"/>
+                <a16:creationId xmlns:a16="http://schemas.microsoft.com/office/drawing/2014/main" id="{EB0BC57F-0BED-F5C5-13C6-DFE7EB9ACA11}"/>
               </a:ext>
             </a:extLst>
           </p:cNvPr>
@@ -8402,7 +8402,7 @@
           <p:cNvPr id="12" name="TextBox 11">
             <a:extLst>
               <a:ext uri="{FF2B5EF4-FFF2-40B4-BE49-F238E27FC236}">
-                <a16:creationId xmlns:a16="http://schemas.microsoft.com/office/drawing/2014/main" id="{B5A5B9F2-8EA5-189B-DFF0-853394806FFC}"/>
+                <a16:creationId xmlns:a16="http://schemas.microsoft.com/office/drawing/2014/main" id="{57C7B619-2729-1FC2-EC86-635A2BCEF539}"/>
               </a:ext>
             </a:extLst>
           </p:cNvPr>
@@ -8527,7 +8527,7 @@
           <p:cNvPr id="13" name="TextBox 12">
             <a:extLst>
               <a:ext uri="{FF2B5EF4-FFF2-40B4-BE49-F238E27FC236}">
-                <a16:creationId xmlns:a16="http://schemas.microsoft.com/office/drawing/2014/main" id="{19770F11-CACE-C57C-6213-E38A8C688B61}"/>
+                <a16:creationId xmlns:a16="http://schemas.microsoft.com/office/drawing/2014/main" id="{C00D851B-2CC2-5BC5-4FA0-9C7D2204EC14}"/>
               </a:ext>
             </a:extLst>
           </p:cNvPr>
@@ -8566,7 +8566,7 @@
     </p:spTree>
     <p:extLst>
       <p:ext uri="{BB962C8B-B14F-4D97-AF65-F5344CB8AC3E}">
-        <p14:creationId xmlns:p14="http://schemas.microsoft.com/office/powerpoint/2010/main" val="3010819670"/>
+        <p14:creationId xmlns:p14="http://schemas.microsoft.com/office/powerpoint/2010/main" val="3841425069"/>
       </p:ext>
     </p:extLst>
   </p:cSld>
@@ -8598,7 +8598,7 @@
           <p:cNvPr id="2" name="TextBox 1">
             <a:extLst>
               <a:ext uri="{FF2B5EF4-FFF2-40B4-BE49-F238E27FC236}">
-                <a16:creationId xmlns:a16="http://schemas.microsoft.com/office/drawing/2014/main" id="{555389FB-70A6-F3A3-A31A-E61B15367E4A}"/>
+                <a16:creationId xmlns:a16="http://schemas.microsoft.com/office/drawing/2014/main" id="{3C0FD455-7A3E-E944-F41E-CDD2189AE2E0}"/>
               </a:ext>
             </a:extLst>
           </p:cNvPr>
@@ -8638,7 +8638,7 @@
           <p:cNvPr id="3" name="Straight Connector 2">
             <a:extLst>
               <a:ext uri="{FF2B5EF4-FFF2-40B4-BE49-F238E27FC236}">
-                <a16:creationId xmlns:a16="http://schemas.microsoft.com/office/drawing/2014/main" id="{F6AB3B7D-2E99-0C65-E6A8-3C0FFD022F35}"/>
+                <a16:creationId xmlns:a16="http://schemas.microsoft.com/office/drawing/2014/main" id="{C353BF7C-D9C1-A295-7DD4-55FDC73B0857}"/>
               </a:ext>
             </a:extLst>
           </p:cNvPr>
@@ -8679,7 +8679,7 @@
           <p:cNvPr id="5" name="Picture 4">
             <a:extLst>
               <a:ext uri="{FF2B5EF4-FFF2-40B4-BE49-F238E27FC236}">
-                <a16:creationId xmlns:a16="http://schemas.microsoft.com/office/drawing/2014/main" id="{51A112D1-7497-3B11-64E0-E57F39CC1A1C}"/>
+                <a16:creationId xmlns:a16="http://schemas.microsoft.com/office/drawing/2014/main" id="{B7965855-66DC-010A-E1F7-CA017F3C6536}"/>
               </a:ext>
             </a:extLst>
           </p:cNvPr>
@@ -8715,7 +8715,7 @@
           <p:cNvPr id="6" name="TextBox 5">
             <a:extLst>
               <a:ext uri="{FF2B5EF4-FFF2-40B4-BE49-F238E27FC236}">
-                <a16:creationId xmlns:a16="http://schemas.microsoft.com/office/drawing/2014/main" id="{09F57F3B-0258-E521-303A-6E8A56D282F3}"/>
+                <a16:creationId xmlns:a16="http://schemas.microsoft.com/office/drawing/2014/main" id="{0500D3BA-A292-856E-3088-B878B6A3922F}"/>
               </a:ext>
             </a:extLst>
           </p:cNvPr>
@@ -8854,7 +8854,7 @@
                 </a:solidFill>
                 <a:latin typeface="Calibri" panose="020F0502020204030204" pitchFamily="34" charset="0"/>
               </a:rPr>
-              <a:t> about 5 ms per prediction on a laptop CPU.</a:t>
+              <a:t> 6 ms or less per prediction on a laptop CPU.</a:t>
             </a:r>
             <a:endParaRPr lang="en-IN" sz="1700">
               <a:solidFill>
@@ -8870,7 +8870,7 @@
           <p:cNvPr id="7" name="TextBox 6">
             <a:extLst>
               <a:ext uri="{FF2B5EF4-FFF2-40B4-BE49-F238E27FC236}">
-                <a16:creationId xmlns:a16="http://schemas.microsoft.com/office/drawing/2014/main" id="{CB76525C-B66F-5639-82F7-515E05A789CF}"/>
+                <a16:creationId xmlns:a16="http://schemas.microsoft.com/office/drawing/2014/main" id="{757ACF97-7856-867F-3A14-EC75D99E04C2}"/>
               </a:ext>
             </a:extLst>
           </p:cNvPr>
@@ -8909,7 +8909,7 @@
     </p:spTree>
     <p:extLst>
       <p:ext uri="{BB962C8B-B14F-4D97-AF65-F5344CB8AC3E}">
-        <p14:creationId xmlns:p14="http://schemas.microsoft.com/office/powerpoint/2010/main" val="2306881519"/>
+        <p14:creationId xmlns:p14="http://schemas.microsoft.com/office/powerpoint/2010/main" val="4002692506"/>
       </p:ext>
     </p:extLst>
   </p:cSld>
@@ -8941,7 +8941,7 @@
           <p:cNvPr id="2" name="TextBox 1">
             <a:extLst>
               <a:ext uri="{FF2B5EF4-FFF2-40B4-BE49-F238E27FC236}">
-                <a16:creationId xmlns:a16="http://schemas.microsoft.com/office/drawing/2014/main" id="{6AE4E729-279D-7FE8-C4EB-5DF4EDB3FD16}"/>
+                <a16:creationId xmlns:a16="http://schemas.microsoft.com/office/drawing/2014/main" id="{818EC320-DE3B-2F66-C83F-63CC0912C2D7}"/>
               </a:ext>
             </a:extLst>
           </p:cNvPr>
@@ -8987,7 +8987,7 @@
           <p:cNvPr id="3" name="Straight Connector 2">
             <a:extLst>
               <a:ext uri="{FF2B5EF4-FFF2-40B4-BE49-F238E27FC236}">
-                <a16:creationId xmlns:a16="http://schemas.microsoft.com/office/drawing/2014/main" id="{0C427D89-58E4-DC1B-3E01-F8C44A960CB5}"/>
+                <a16:creationId xmlns:a16="http://schemas.microsoft.com/office/drawing/2014/main" id="{668D7537-B2AA-A890-7E09-F2F808638E4C}"/>
               </a:ext>
             </a:extLst>
           </p:cNvPr>
@@ -9028,7 +9028,7 @@
           <p:cNvPr id="5" name="Picture 4">
             <a:extLst>
               <a:ext uri="{FF2B5EF4-FFF2-40B4-BE49-F238E27FC236}">
-                <a16:creationId xmlns:a16="http://schemas.microsoft.com/office/drawing/2014/main" id="{2DD5DD1F-EAF5-5128-440D-476A9CFDD487}"/>
+                <a16:creationId xmlns:a16="http://schemas.microsoft.com/office/drawing/2014/main" id="{ECA1096B-BF60-B133-6AC3-C8867D875F53}"/>
               </a:ext>
             </a:extLst>
           </p:cNvPr>
@@ -9064,7 +9064,7 @@
           <p:cNvPr id="6" name="TextBox 5">
             <a:extLst>
               <a:ext uri="{FF2B5EF4-FFF2-40B4-BE49-F238E27FC236}">
-                <a16:creationId xmlns:a16="http://schemas.microsoft.com/office/drawing/2014/main" id="{9DE0160C-34C2-FC8D-4614-82D54EC6410B}"/>
+                <a16:creationId xmlns:a16="http://schemas.microsoft.com/office/drawing/2014/main" id="{0DBA511A-A64B-54E9-BDE2-C3DBC5C36B08}"/>
               </a:ext>
             </a:extLst>
           </p:cNvPr>
@@ -9219,7 +9219,7 @@
           <p:cNvPr id="7" name="TextBox 6">
             <a:extLst>
               <a:ext uri="{FF2B5EF4-FFF2-40B4-BE49-F238E27FC236}">
-                <a16:creationId xmlns:a16="http://schemas.microsoft.com/office/drawing/2014/main" id="{BE3B7CC8-6CE6-D4C9-0500-8FE2A65F59A7}"/>
+                <a16:creationId xmlns:a16="http://schemas.microsoft.com/office/drawing/2014/main" id="{52ABB711-30CE-CE5A-7A26-93F07BE1F726}"/>
               </a:ext>
             </a:extLst>
           </p:cNvPr>
@@ -9258,7 +9258,7 @@
     </p:spTree>
     <p:extLst>
       <p:ext uri="{BB962C8B-B14F-4D97-AF65-F5344CB8AC3E}">
-        <p14:creationId xmlns:p14="http://schemas.microsoft.com/office/powerpoint/2010/main" val="2881870676"/>
+        <p14:creationId xmlns:p14="http://schemas.microsoft.com/office/powerpoint/2010/main" val="38216456"/>
       </p:ext>
     </p:extLst>
   </p:cSld>
@@ -9290,7 +9290,7 @@
           <p:cNvPr id="2" name="TextBox 1">
             <a:extLst>
               <a:ext uri="{FF2B5EF4-FFF2-40B4-BE49-F238E27FC236}">
-                <a16:creationId xmlns:a16="http://schemas.microsoft.com/office/drawing/2014/main" id="{2A35A7AD-3A98-8AC3-3695-9828D6135A63}"/>
+                <a16:creationId xmlns:a16="http://schemas.microsoft.com/office/drawing/2014/main" id="{26AE2047-E7DE-6200-6B11-9398C71EAE4D}"/>
               </a:ext>
             </a:extLst>
           </p:cNvPr>
@@ -9336,7 +9336,7 @@
           <p:cNvPr id="3" name="Straight Connector 2">
             <a:extLst>
               <a:ext uri="{FF2B5EF4-FFF2-40B4-BE49-F238E27FC236}">
-                <a16:creationId xmlns:a16="http://schemas.microsoft.com/office/drawing/2014/main" id="{9A274F77-9FFF-75D1-BE43-81A2470C5635}"/>
+                <a16:creationId xmlns:a16="http://schemas.microsoft.com/office/drawing/2014/main" id="{3EA1A751-F5F3-291E-303F-261C50C514B1}"/>
               </a:ext>
             </a:extLst>
           </p:cNvPr>
@@ -9377,7 +9377,7 @@
           <p:cNvPr id="4" name="TextBox 3">
             <a:extLst>
               <a:ext uri="{FF2B5EF4-FFF2-40B4-BE49-F238E27FC236}">
-                <a16:creationId xmlns:a16="http://schemas.microsoft.com/office/drawing/2014/main" id="{CC22D285-FA43-A7FE-CDC9-43256B6887F6}"/>
+                <a16:creationId xmlns:a16="http://schemas.microsoft.com/office/drawing/2014/main" id="{6E4F1B3E-9E28-C2C4-EAE4-FAE7CDBA370A}"/>
               </a:ext>
             </a:extLst>
           </p:cNvPr>
@@ -9428,7 +9428,7 @@
           <p:cNvPr id="5" name="Table 4">
             <a:extLst>
               <a:ext uri="{FF2B5EF4-FFF2-40B4-BE49-F238E27FC236}">
-                <a16:creationId xmlns:a16="http://schemas.microsoft.com/office/drawing/2014/main" id="{3DAB3201-9662-F4DF-583C-472776EC0098}"/>
+                <a16:creationId xmlns:a16="http://schemas.microsoft.com/office/drawing/2014/main" id="{77631646-E809-6C60-3A88-8E27490742ED}"/>
               </a:ext>
             </a:extLst>
           </p:cNvPr>
@@ -9438,7 +9438,7 @@
           <p:nvPr>
             <p:extLst>
               <p:ext uri="{D42A27DB-BD31-4B8C-83A1-F6EECF244321}">
-                <p14:modId xmlns:p14="http://schemas.microsoft.com/office/powerpoint/2010/main" val="49290799"/>
+                <p14:modId xmlns:p14="http://schemas.microsoft.com/office/powerpoint/2010/main" val="3493751097"/>
               </p:ext>
             </p:extLst>
           </p:nvPr>
@@ -9457,21 +9457,21 @@
                 <a:gridCol w="2560320">
                   <a:extLst>
                     <a:ext uri="{9D8B030D-6E8A-4147-A177-3AD203B41FA5}">
-                      <a16:colId xmlns:a16="http://schemas.microsoft.com/office/drawing/2014/main" val="595088575"/>
+                      <a16:colId xmlns:a16="http://schemas.microsoft.com/office/drawing/2014/main" val="3243053648"/>
                     </a:ext>
                   </a:extLst>
                 </a:gridCol>
                 <a:gridCol w="1463040">
                   <a:extLst>
                     <a:ext uri="{9D8B030D-6E8A-4147-A177-3AD203B41FA5}">
-                      <a16:colId xmlns:a16="http://schemas.microsoft.com/office/drawing/2014/main" val="3770972863"/>
+                      <a16:colId xmlns:a16="http://schemas.microsoft.com/office/drawing/2014/main" val="652850138"/>
                     </a:ext>
                   </a:extLst>
                 </a:gridCol>
                 <a:gridCol w="1463040">
                   <a:extLst>
                     <a:ext uri="{9D8B030D-6E8A-4147-A177-3AD203B41FA5}">
-                      <a16:colId xmlns:a16="http://schemas.microsoft.com/office/drawing/2014/main" val="1661763404"/>
+                      <a16:colId xmlns:a16="http://schemas.microsoft.com/office/drawing/2014/main" val="4083250972"/>
                     </a:ext>
                   </a:extLst>
                 </a:gridCol>
@@ -9548,7 +9548,7 @@
                 </a:tc>
                 <a:extLst>
                   <a:ext uri="{0D108BD9-81ED-4DB2-BD59-A6C34878D82A}">
-                    <a16:rowId xmlns:a16="http://schemas.microsoft.com/office/drawing/2014/main" val="3615512538"/>
+                    <a16:rowId xmlns:a16="http://schemas.microsoft.com/office/drawing/2014/main" val="2262869785"/>
                   </a:ext>
                 </a:extLst>
               </a:tr>
@@ -9624,7 +9624,7 @@
                 </a:tc>
                 <a:extLst>
                   <a:ext uri="{0D108BD9-81ED-4DB2-BD59-A6C34878D82A}">
-                    <a16:rowId xmlns:a16="http://schemas.microsoft.com/office/drawing/2014/main" val="201457179"/>
+                    <a16:rowId xmlns:a16="http://schemas.microsoft.com/office/drawing/2014/main" val="3248458941"/>
                   </a:ext>
                 </a:extLst>
               </a:tr>
@@ -9700,7 +9700,7 @@
                 </a:tc>
                 <a:extLst>
                   <a:ext uri="{0D108BD9-81ED-4DB2-BD59-A6C34878D82A}">
-                    <a16:rowId xmlns:a16="http://schemas.microsoft.com/office/drawing/2014/main" val="1971160709"/>
+                    <a16:rowId xmlns:a16="http://schemas.microsoft.com/office/drawing/2014/main" val="896779357"/>
                   </a:ext>
                 </a:extLst>
               </a:tr>
@@ -9713,7 +9713,7 @@
           <p:cNvPr id="7" name="Picture 6">
             <a:extLst>
               <a:ext uri="{FF2B5EF4-FFF2-40B4-BE49-F238E27FC236}">
-                <a16:creationId xmlns:a16="http://schemas.microsoft.com/office/drawing/2014/main" id="{7AB4201F-836C-A982-E0D8-CCFC0E39633A}"/>
+                <a16:creationId xmlns:a16="http://schemas.microsoft.com/office/drawing/2014/main" id="{260AF13D-C281-2B6C-7B83-710DC9F011E9}"/>
               </a:ext>
             </a:extLst>
           </p:cNvPr>
@@ -9749,7 +9749,7 @@
           <p:cNvPr id="8" name="TextBox 7">
             <a:extLst>
               <a:ext uri="{FF2B5EF4-FFF2-40B4-BE49-F238E27FC236}">
-                <a16:creationId xmlns:a16="http://schemas.microsoft.com/office/drawing/2014/main" id="{626E584C-CD00-F9CF-1948-0ABAFE0C8C73}"/>
+                <a16:creationId xmlns:a16="http://schemas.microsoft.com/office/drawing/2014/main" id="{F69082C0-C8F6-F3AA-F887-77A1E15E7341}"/>
               </a:ext>
             </a:extLst>
           </p:cNvPr>
@@ -9800,7 +9800,7 @@
           <p:cNvPr id="9" name="TextBox 8">
             <a:extLst>
               <a:ext uri="{FF2B5EF4-FFF2-40B4-BE49-F238E27FC236}">
-                <a16:creationId xmlns:a16="http://schemas.microsoft.com/office/drawing/2014/main" id="{5EFA5F75-50A6-831C-12DF-6DCD872E18B3}"/>
+                <a16:creationId xmlns:a16="http://schemas.microsoft.com/office/drawing/2014/main" id="{712856CE-5CFB-D062-F54A-597D61EF263B}"/>
               </a:ext>
             </a:extLst>
           </p:cNvPr>
@@ -9839,7 +9839,7 @@
     </p:spTree>
     <p:extLst>
       <p:ext uri="{BB962C8B-B14F-4D97-AF65-F5344CB8AC3E}">
-        <p14:creationId xmlns:p14="http://schemas.microsoft.com/office/powerpoint/2010/main" val="989654486"/>
+        <p14:creationId xmlns:p14="http://schemas.microsoft.com/office/powerpoint/2010/main" val="3245751485"/>
       </p:ext>
     </p:extLst>
   </p:cSld>
@@ -9871,7 +9871,7 @@
           <p:cNvPr id="2" name="TextBox 1">
             <a:extLst>
               <a:ext uri="{FF2B5EF4-FFF2-40B4-BE49-F238E27FC236}">
-                <a16:creationId xmlns:a16="http://schemas.microsoft.com/office/drawing/2014/main" id="{3698920C-84E4-6486-8462-48526E5F2AFE}"/>
+                <a16:creationId xmlns:a16="http://schemas.microsoft.com/office/drawing/2014/main" id="{9310C7BE-8CA5-2EA8-1374-1E4CE7300A32}"/>
               </a:ext>
             </a:extLst>
           </p:cNvPr>
@@ -9917,7 +9917,7 @@
           <p:cNvPr id="3" name="Straight Connector 2">
             <a:extLst>
               <a:ext uri="{FF2B5EF4-FFF2-40B4-BE49-F238E27FC236}">
-                <a16:creationId xmlns:a16="http://schemas.microsoft.com/office/drawing/2014/main" id="{F2EC77B7-CCAD-05E3-7C79-CF560717669A}"/>
+                <a16:creationId xmlns:a16="http://schemas.microsoft.com/office/drawing/2014/main" id="{E51E3DDE-263C-0773-3B48-945BFDAF4F0E}"/>
               </a:ext>
             </a:extLst>
           </p:cNvPr>
@@ -9958,7 +9958,7 @@
           <p:cNvPr id="4" name="TextBox 3">
             <a:extLst>
               <a:ext uri="{FF2B5EF4-FFF2-40B4-BE49-F238E27FC236}">
-                <a16:creationId xmlns:a16="http://schemas.microsoft.com/office/drawing/2014/main" id="{C8337626-6703-A7CC-9B6C-298965E93A64}"/>
+                <a16:creationId xmlns:a16="http://schemas.microsoft.com/office/drawing/2014/main" id="{7A5E637C-BB8D-4CFA-66D6-999F47BA7BF5}"/>
               </a:ext>
             </a:extLst>
           </p:cNvPr>
@@ -10009,7 +10009,7 @@
           <p:cNvPr id="6" name="Picture 5">
             <a:extLst>
               <a:ext uri="{FF2B5EF4-FFF2-40B4-BE49-F238E27FC236}">
-                <a16:creationId xmlns:a16="http://schemas.microsoft.com/office/drawing/2014/main" id="{CE0AE5DF-51D7-7B4F-23FB-6296D4973AD5}"/>
+                <a16:creationId xmlns:a16="http://schemas.microsoft.com/office/drawing/2014/main" id="{3263E059-4026-A1E7-E517-FBBAEB3667F0}"/>
               </a:ext>
             </a:extLst>
           </p:cNvPr>
@@ -10045,7 +10045,7 @@
           <p:cNvPr id="7" name="Rectangle: Rounded Corners 6">
             <a:extLst>
               <a:ext uri="{FF2B5EF4-FFF2-40B4-BE49-F238E27FC236}">
-                <a16:creationId xmlns:a16="http://schemas.microsoft.com/office/drawing/2014/main" id="{811C95DA-CE64-F896-DD24-B0255460A75E}"/>
+                <a16:creationId xmlns:a16="http://schemas.microsoft.com/office/drawing/2014/main" id="{18B0193A-3047-79EE-9894-7E46B8349944}"/>
               </a:ext>
             </a:extLst>
           </p:cNvPr>
@@ -10123,7 +10123,7 @@
           <p:cNvPr id="8" name="Rectangle: Rounded Corners 7">
             <a:extLst>
               <a:ext uri="{FF2B5EF4-FFF2-40B4-BE49-F238E27FC236}">
-                <a16:creationId xmlns:a16="http://schemas.microsoft.com/office/drawing/2014/main" id="{E573BF83-FD09-8E08-C7B9-C03CC56CEAD3}"/>
+                <a16:creationId xmlns:a16="http://schemas.microsoft.com/office/drawing/2014/main" id="{96F55858-FF62-A4FE-7FDC-BCB846255617}"/>
               </a:ext>
             </a:extLst>
           </p:cNvPr>
@@ -10201,7 +10201,7 @@
           <p:cNvPr id="9" name="Rectangle: Rounded Corners 8">
             <a:extLst>
               <a:ext uri="{FF2B5EF4-FFF2-40B4-BE49-F238E27FC236}">
-                <a16:creationId xmlns:a16="http://schemas.microsoft.com/office/drawing/2014/main" id="{D7C56031-F713-911A-55A5-9153981266C8}"/>
+                <a16:creationId xmlns:a16="http://schemas.microsoft.com/office/drawing/2014/main" id="{17238497-BC92-2251-1B33-B4B3CE5EF727}"/>
               </a:ext>
             </a:extLst>
           </p:cNvPr>
@@ -10279,7 +10279,7 @@
           <p:cNvPr id="10" name="TextBox 9">
             <a:extLst>
               <a:ext uri="{FF2B5EF4-FFF2-40B4-BE49-F238E27FC236}">
-                <a16:creationId xmlns:a16="http://schemas.microsoft.com/office/drawing/2014/main" id="{78E9C040-4956-270D-9DAE-C49173B8420A}"/>
+                <a16:creationId xmlns:a16="http://schemas.microsoft.com/office/drawing/2014/main" id="{9FEB3679-D8C8-98B7-980C-12DD2CAE2833}"/>
               </a:ext>
             </a:extLst>
           </p:cNvPr>
@@ -10324,7 +10324,7 @@
           <p:cNvPr id="11" name="TextBox 10">
             <a:extLst>
               <a:ext uri="{FF2B5EF4-FFF2-40B4-BE49-F238E27FC236}">
-                <a16:creationId xmlns:a16="http://schemas.microsoft.com/office/drawing/2014/main" id="{65C50338-14A7-FE89-59D7-9988ECE528E6}"/>
+                <a16:creationId xmlns:a16="http://schemas.microsoft.com/office/drawing/2014/main" id="{64C8938A-2D6D-BB5F-F40C-F8C8DED3FB90}"/>
               </a:ext>
             </a:extLst>
           </p:cNvPr>
@@ -10375,7 +10375,7 @@
           <p:cNvPr id="12" name="TextBox 11">
             <a:extLst>
               <a:ext uri="{FF2B5EF4-FFF2-40B4-BE49-F238E27FC236}">
-                <a16:creationId xmlns:a16="http://schemas.microsoft.com/office/drawing/2014/main" id="{9DF7989B-5AFF-ED01-77BC-B5BF37CD8461}"/>
+                <a16:creationId xmlns:a16="http://schemas.microsoft.com/office/drawing/2014/main" id="{7280175C-CBC0-6EE0-DE6B-6771A95E75B0}"/>
               </a:ext>
             </a:extLst>
           </p:cNvPr>
@@ -10420,7 +10420,7 @@
           <p:cNvPr id="13" name="TextBox 12">
             <a:extLst>
               <a:ext uri="{FF2B5EF4-FFF2-40B4-BE49-F238E27FC236}">
-                <a16:creationId xmlns:a16="http://schemas.microsoft.com/office/drawing/2014/main" id="{1418B9ED-9559-A714-D8B8-F378310A55D4}"/>
+                <a16:creationId xmlns:a16="http://schemas.microsoft.com/office/drawing/2014/main" id="{A452F7C4-AEA2-5A65-0E1D-A7FD198B9AC4}"/>
               </a:ext>
             </a:extLst>
           </p:cNvPr>
@@ -10459,7 +10459,7 @@
     </p:spTree>
     <p:extLst>
       <p:ext uri="{BB962C8B-B14F-4D97-AF65-F5344CB8AC3E}">
-        <p14:creationId xmlns:p14="http://schemas.microsoft.com/office/powerpoint/2010/main" val="3906866854"/>
+        <p14:creationId xmlns:p14="http://schemas.microsoft.com/office/powerpoint/2010/main" val="1928032992"/>
       </p:ext>
     </p:extLst>
   </p:cSld>
@@ -10491,7 +10491,7 @@
           <p:cNvPr id="2" name="TextBox 1">
             <a:extLst>
               <a:ext uri="{FF2B5EF4-FFF2-40B4-BE49-F238E27FC236}">
-                <a16:creationId xmlns:a16="http://schemas.microsoft.com/office/drawing/2014/main" id="{D678BF03-18CE-0E97-664F-21C955990FD3}"/>
+                <a16:creationId xmlns:a16="http://schemas.microsoft.com/office/drawing/2014/main" id="{ABDFBF29-0A3A-59A0-6001-BD9BCCA27C54}"/>
               </a:ext>
             </a:extLst>
           </p:cNvPr>
@@ -10537,7 +10537,7 @@
           <p:cNvPr id="3" name="Straight Connector 2">
             <a:extLst>
               <a:ext uri="{FF2B5EF4-FFF2-40B4-BE49-F238E27FC236}">
-                <a16:creationId xmlns:a16="http://schemas.microsoft.com/office/drawing/2014/main" id="{8E159F50-25F9-0FCD-D4F8-C43FD6A7AE7E}"/>
+                <a16:creationId xmlns:a16="http://schemas.microsoft.com/office/drawing/2014/main" id="{DD975B18-8677-D5C1-DFA7-142E162F586A}"/>
               </a:ext>
             </a:extLst>
           </p:cNvPr>
@@ -10578,7 +10578,7 @@
           <p:cNvPr id="5" name="Picture 4">
             <a:extLst>
               <a:ext uri="{FF2B5EF4-FFF2-40B4-BE49-F238E27FC236}">
-                <a16:creationId xmlns:a16="http://schemas.microsoft.com/office/drawing/2014/main" id="{BAF6C396-4A87-9F19-3483-7BD89B186A9D}"/>
+                <a16:creationId xmlns:a16="http://schemas.microsoft.com/office/drawing/2014/main" id="{D1694364-8980-4C87-237E-A6237ABF5D85}"/>
               </a:ext>
             </a:extLst>
           </p:cNvPr>
@@ -10614,7 +10614,7 @@
           <p:cNvPr id="6" name="TextBox 5">
             <a:extLst>
               <a:ext uri="{FF2B5EF4-FFF2-40B4-BE49-F238E27FC236}">
-                <a16:creationId xmlns:a16="http://schemas.microsoft.com/office/drawing/2014/main" id="{1356835F-16CF-C23F-238B-BF866EFD0FB4}"/>
+                <a16:creationId xmlns:a16="http://schemas.microsoft.com/office/drawing/2014/main" id="{11B08EE4-2657-844F-AEBE-16B44F5B87CA}"/>
               </a:ext>
             </a:extLst>
           </p:cNvPr>
@@ -10659,7 +10659,7 @@
           <p:cNvPr id="7" name="TextBox 6">
             <a:extLst>
               <a:ext uri="{FF2B5EF4-FFF2-40B4-BE49-F238E27FC236}">
-                <a16:creationId xmlns:a16="http://schemas.microsoft.com/office/drawing/2014/main" id="{CACFBD3E-3866-EDA4-B662-8B8ADCA3561D}"/>
+                <a16:creationId xmlns:a16="http://schemas.microsoft.com/office/drawing/2014/main" id="{7DF5ECF0-47D3-8C2D-F4B8-77D0993605CA}"/>
               </a:ext>
             </a:extLst>
           </p:cNvPr>
@@ -10726,7 +10726,7 @@
           <p:cNvPr id="8" name="TextBox 7">
             <a:extLst>
               <a:ext uri="{FF2B5EF4-FFF2-40B4-BE49-F238E27FC236}">
-                <a16:creationId xmlns:a16="http://schemas.microsoft.com/office/drawing/2014/main" id="{E69AB2B5-2676-6E24-8DA3-D941C21A853D}"/>
+                <a16:creationId xmlns:a16="http://schemas.microsoft.com/office/drawing/2014/main" id="{32431865-093C-40A1-5273-FC67989C03A0}"/>
               </a:ext>
             </a:extLst>
           </p:cNvPr>
@@ -10771,7 +10771,7 @@
           <p:cNvPr id="9" name="TextBox 8">
             <a:extLst>
               <a:ext uri="{FF2B5EF4-FFF2-40B4-BE49-F238E27FC236}">
-                <a16:creationId xmlns:a16="http://schemas.microsoft.com/office/drawing/2014/main" id="{289435CD-1B1C-7BC1-53A3-8A6B7E654A24}"/>
+                <a16:creationId xmlns:a16="http://schemas.microsoft.com/office/drawing/2014/main" id="{B2C4DD54-E4F4-C1CC-B482-FAA78B7269F5}"/>
               </a:ext>
             </a:extLst>
           </p:cNvPr>
@@ -10816,7 +10816,7 @@
           <p:cNvPr id="10" name="TextBox 9">
             <a:extLst>
               <a:ext uri="{FF2B5EF4-FFF2-40B4-BE49-F238E27FC236}">
-                <a16:creationId xmlns:a16="http://schemas.microsoft.com/office/drawing/2014/main" id="{4E5A4571-81A0-4EB5-0187-77445FF5C93E}"/>
+                <a16:creationId xmlns:a16="http://schemas.microsoft.com/office/drawing/2014/main" id="{5AD44848-C4FE-73DA-46D4-65F5DAC5C8E3}"/>
               </a:ext>
             </a:extLst>
           </p:cNvPr>
@@ -10911,7 +10911,7 @@
           <p:cNvPr id="11" name="TextBox 10">
             <a:extLst>
               <a:ext uri="{FF2B5EF4-FFF2-40B4-BE49-F238E27FC236}">
-                <a16:creationId xmlns:a16="http://schemas.microsoft.com/office/drawing/2014/main" id="{42B69DCD-2393-A584-B355-FD393803E951}"/>
+                <a16:creationId xmlns:a16="http://schemas.microsoft.com/office/drawing/2014/main" id="{442CB54F-9746-06DB-FB46-A08DE8DFFFED}"/>
               </a:ext>
             </a:extLst>
           </p:cNvPr>
@@ -10950,7 +10950,7 @@
     </p:spTree>
     <p:extLst>
       <p:ext uri="{BB962C8B-B14F-4D97-AF65-F5344CB8AC3E}">
-        <p14:creationId xmlns:p14="http://schemas.microsoft.com/office/powerpoint/2010/main" val="199301099"/>
+        <p14:creationId xmlns:p14="http://schemas.microsoft.com/office/powerpoint/2010/main" val="1365433031"/>
       </p:ext>
     </p:extLst>
   </p:cSld>

</xml_diff>